<commit_message>
log rank exercises and datasets
</commit_message>
<xml_diff>
--- a/materials/images/repo-figures.pptx
+++ b/materials/images/repo-figures.pptx
@@ -11,6 +11,8 @@
     <p:sldId id="259" r:id="rId5"/>
     <p:sldId id="260" r:id="rId6"/>
     <p:sldId id="261" r:id="rId7"/>
+    <p:sldId id="262" r:id="rId8"/>
+    <p:sldId id="263" r:id="rId9"/>
   </p:sldIdLst>
   <p:sldSz cx="12192000" cy="6858000"/>
   <p:notesSz cx="6858000" cy="9144000"/>
@@ -266,7 +268,7 @@
           <a:p>
             <a:fld id="{E2E4B5E3-46D6-4573-8542-0B344A7439ED}" type="datetimeFigureOut">
               <a:rPr lang="en-GB" smtClean="0"/>
-              <a:t>08/06/2026</a:t>
+              <a:t>18/08/2026</a:t>
             </a:fld>
             <a:endParaRPr lang="en-GB"/>
           </a:p>
@@ -466,7 +468,7 @@
           <a:p>
             <a:fld id="{E2E4B5E3-46D6-4573-8542-0B344A7439ED}" type="datetimeFigureOut">
               <a:rPr lang="en-GB" smtClean="0"/>
-              <a:t>08/06/2026</a:t>
+              <a:t>18/08/2026</a:t>
             </a:fld>
             <a:endParaRPr lang="en-GB"/>
           </a:p>
@@ -676,7 +678,7 @@
           <a:p>
             <a:fld id="{E2E4B5E3-46D6-4573-8542-0B344A7439ED}" type="datetimeFigureOut">
               <a:rPr lang="en-GB" smtClean="0"/>
-              <a:t>08/06/2026</a:t>
+              <a:t>18/08/2026</a:t>
             </a:fld>
             <a:endParaRPr lang="en-GB"/>
           </a:p>
@@ -876,7 +878,7 @@
           <a:p>
             <a:fld id="{E2E4B5E3-46D6-4573-8542-0B344A7439ED}" type="datetimeFigureOut">
               <a:rPr lang="en-GB" smtClean="0"/>
-              <a:t>08/06/2026</a:t>
+              <a:t>18/08/2026</a:t>
             </a:fld>
             <a:endParaRPr lang="en-GB"/>
           </a:p>
@@ -1152,7 +1154,7 @@
           <a:p>
             <a:fld id="{E2E4B5E3-46D6-4573-8542-0B344A7439ED}" type="datetimeFigureOut">
               <a:rPr lang="en-GB" smtClean="0"/>
-              <a:t>08/06/2026</a:t>
+              <a:t>18/08/2026</a:t>
             </a:fld>
             <a:endParaRPr lang="en-GB"/>
           </a:p>
@@ -1420,7 +1422,7 @@
           <a:p>
             <a:fld id="{E2E4B5E3-46D6-4573-8542-0B344A7439ED}" type="datetimeFigureOut">
               <a:rPr lang="en-GB" smtClean="0"/>
-              <a:t>08/06/2026</a:t>
+              <a:t>18/08/2026</a:t>
             </a:fld>
             <a:endParaRPr lang="en-GB"/>
           </a:p>
@@ -1835,7 +1837,7 @@
           <a:p>
             <a:fld id="{E2E4B5E3-46D6-4573-8542-0B344A7439ED}" type="datetimeFigureOut">
               <a:rPr lang="en-GB" smtClean="0"/>
-              <a:t>08/06/2026</a:t>
+              <a:t>18/08/2026</a:t>
             </a:fld>
             <a:endParaRPr lang="en-GB"/>
           </a:p>
@@ -1977,7 +1979,7 @@
           <a:p>
             <a:fld id="{E2E4B5E3-46D6-4573-8542-0B344A7439ED}" type="datetimeFigureOut">
               <a:rPr lang="en-GB" smtClean="0"/>
-              <a:t>08/06/2026</a:t>
+              <a:t>18/08/2026</a:t>
             </a:fld>
             <a:endParaRPr lang="en-GB"/>
           </a:p>
@@ -2090,7 +2092,7 @@
           <a:p>
             <a:fld id="{E2E4B5E3-46D6-4573-8542-0B344A7439ED}" type="datetimeFigureOut">
               <a:rPr lang="en-GB" smtClean="0"/>
-              <a:t>08/06/2026</a:t>
+              <a:t>18/08/2026</a:t>
             </a:fld>
             <a:endParaRPr lang="en-GB"/>
           </a:p>
@@ -2403,7 +2405,7 @@
           <a:p>
             <a:fld id="{E2E4B5E3-46D6-4573-8542-0B344A7439ED}" type="datetimeFigureOut">
               <a:rPr lang="en-GB" smtClean="0"/>
-              <a:t>08/06/2026</a:t>
+              <a:t>18/08/2026</a:t>
             </a:fld>
             <a:endParaRPr lang="en-GB"/>
           </a:p>
@@ -2692,7 +2694,7 @@
           <a:p>
             <a:fld id="{E2E4B5E3-46D6-4573-8542-0B344A7439ED}" type="datetimeFigureOut">
               <a:rPr lang="en-GB" smtClean="0"/>
-              <a:t>08/06/2026</a:t>
+              <a:t>18/08/2026</a:t>
             </a:fld>
             <a:endParaRPr lang="en-GB"/>
           </a:p>
@@ -2935,7 +2937,7 @@
           <a:p>
             <a:fld id="{E2E4B5E3-46D6-4573-8542-0B344A7439ED}" type="datetimeFigureOut">
               <a:rPr lang="en-GB" smtClean="0"/>
-              <a:t>08/06/2026</a:t>
+              <a:t>18/08/2026</a:t>
             </a:fld>
             <a:endParaRPr lang="en-GB"/>
           </a:p>
@@ -9620,6 +9622,2944 @@
 </p:sld>
 </file>
 
+<file path=ppt/slides/slide7.xml><?xml version="1.0" encoding="utf-8"?>
+<p:sld xmlns:a="http://schemas.openxmlformats.org/drawingml/2006/main" xmlns:r="http://schemas.openxmlformats.org/officeDocument/2006/relationships" xmlns:p="http://schemas.openxmlformats.org/presentationml/2006/main">
+  <p:cSld>
+    <p:spTree>
+      <p:nvGrpSpPr>
+        <p:cNvPr id="1" name=""/>
+        <p:cNvGrpSpPr/>
+        <p:nvPr/>
+      </p:nvGrpSpPr>
+      <p:grpSpPr>
+        <a:xfrm>
+          <a:off x="0" y="0"/>
+          <a:ext cx="0" cy="0"/>
+          <a:chOff x="0" y="0"/>
+          <a:chExt cx="0" cy="0"/>
+        </a:xfrm>
+      </p:grpSpPr>
+      <p:sp>
+        <p:nvSpPr>
+          <p:cNvPr id="45" name="Rectangle 44">
+            <a:extLst>
+              <a:ext uri="{FF2B5EF4-FFF2-40B4-BE49-F238E27FC236}">
+                <a16:creationId xmlns:a16="http://schemas.microsoft.com/office/drawing/2014/main" id="{CD7005D8-B3F4-C95B-183A-FBC3B564ED4F}"/>
+              </a:ext>
+            </a:extLst>
+          </p:cNvPr>
+          <p:cNvSpPr/>
+          <p:nvPr/>
+        </p:nvSpPr>
+        <p:spPr>
+          <a:xfrm>
+            <a:off x="553633" y="819806"/>
+            <a:ext cx="10620000" cy="3294993"/>
+          </a:xfrm>
+          <a:prstGeom prst="rect">
+            <a:avLst/>
+          </a:prstGeom>
+          <a:solidFill>
+            <a:schemeClr val="bg1"/>
+          </a:solidFill>
+          <a:ln>
+            <a:noFill/>
+          </a:ln>
+        </p:spPr>
+        <p:style>
+          <a:lnRef idx="2">
+            <a:schemeClr val="accent1">
+              <a:shade val="15000"/>
+            </a:schemeClr>
+          </a:lnRef>
+          <a:fillRef idx="1">
+            <a:schemeClr val="accent1"/>
+          </a:fillRef>
+          <a:effectRef idx="0">
+            <a:schemeClr val="accent1"/>
+          </a:effectRef>
+          <a:fontRef idx="minor">
+            <a:schemeClr val="lt1"/>
+          </a:fontRef>
+        </p:style>
+        <p:txBody>
+          <a:bodyPr rtlCol="0" anchor="ctr"/>
+          <a:lstStyle/>
+          <a:p>
+            <a:pPr algn="ctr"/>
+            <a:endParaRPr lang="en-GB"/>
+          </a:p>
+        </p:txBody>
+      </p:sp>
+      <p:grpSp>
+        <p:nvGrpSpPr>
+          <p:cNvPr id="2" name="Group 1">
+            <a:extLst>
+              <a:ext uri="{FF2B5EF4-FFF2-40B4-BE49-F238E27FC236}">
+                <a16:creationId xmlns:a16="http://schemas.microsoft.com/office/drawing/2014/main" id="{485E4B46-601B-B5AD-631F-6260028F3B9C}"/>
+              </a:ext>
+            </a:extLst>
+          </p:cNvPr>
+          <p:cNvGrpSpPr/>
+          <p:nvPr/>
+        </p:nvGrpSpPr>
+        <p:grpSpPr>
+          <a:xfrm>
+            <a:off x="1168851" y="929432"/>
+            <a:ext cx="4626351" cy="3048669"/>
+            <a:chOff x="1423978" y="2670416"/>
+            <a:chExt cx="4626351" cy="3048669"/>
+          </a:xfrm>
+        </p:grpSpPr>
+        <p:sp>
+          <p:nvSpPr>
+            <p:cNvPr id="3" name="Arrow: Right 2">
+              <a:extLst>
+                <a:ext uri="{FF2B5EF4-FFF2-40B4-BE49-F238E27FC236}">
+                  <a16:creationId xmlns:a16="http://schemas.microsoft.com/office/drawing/2014/main" id="{39DEEC71-EA13-8432-ABBD-A97430FFB19F}"/>
+                </a:ext>
+              </a:extLst>
+            </p:cNvPr>
+            <p:cNvSpPr/>
+            <p:nvPr/>
+          </p:nvSpPr>
+          <p:spPr>
+            <a:xfrm>
+              <a:off x="1786417" y="3344858"/>
+              <a:ext cx="2609290" cy="353083"/>
+            </a:xfrm>
+            <a:prstGeom prst="rightArrow">
+              <a:avLst/>
+            </a:prstGeom>
+            <a:solidFill>
+              <a:srgbClr val="00B1C1"/>
+            </a:solidFill>
+            <a:ln>
+              <a:solidFill>
+                <a:schemeClr val="accent2"/>
+              </a:solidFill>
+            </a:ln>
+          </p:spPr>
+          <p:style>
+            <a:lnRef idx="2">
+              <a:schemeClr val="accent1">
+                <a:shade val="15000"/>
+              </a:schemeClr>
+            </a:lnRef>
+            <a:fillRef idx="1">
+              <a:schemeClr val="accent1"/>
+            </a:fillRef>
+            <a:effectRef idx="0">
+              <a:schemeClr val="accent1"/>
+            </a:effectRef>
+            <a:fontRef idx="minor">
+              <a:schemeClr val="lt1"/>
+            </a:fontRef>
+          </p:style>
+          <p:txBody>
+            <a:bodyPr rtlCol="0" anchor="ctr"/>
+            <a:lstStyle/>
+            <a:p>
+              <a:pPr algn="ctr"/>
+              <a:endParaRPr lang="en-GB"/>
+            </a:p>
+          </p:txBody>
+        </p:sp>
+        <p:pic>
+          <p:nvPicPr>
+            <p:cNvPr id="4" name="Graphic 3" descr="Dinosaur Egg with solid fill">
+              <a:extLst>
+                <a:ext uri="{FF2B5EF4-FFF2-40B4-BE49-F238E27FC236}">
+                  <a16:creationId xmlns:a16="http://schemas.microsoft.com/office/drawing/2014/main" id="{9EF0B0BF-A455-0167-A8F0-4AAD0DE87C15}"/>
+                </a:ext>
+              </a:extLst>
+            </p:cNvPr>
+            <p:cNvPicPr>
+              <a:picLocks noChangeAspect="1"/>
+            </p:cNvPicPr>
+            <p:nvPr/>
+          </p:nvPicPr>
+          <p:blipFill>
+            <a:blip>
+              <a:extLst>
+                <a:ext uri="{96DAC541-7B7A-43D3-8B79-37D633B846F1}">
+                  <asvg:svgBlip xmlns:asvg="http://schemas.microsoft.com/office/drawing/2016/SVG/main" r:embed="rId2"/>
+                </a:ext>
+              </a:extLst>
+            </a:blip>
+            <a:srcRect/>
+            <a:stretch/>
+          </p:blipFill>
+          <p:spPr>
+            <a:xfrm>
+              <a:off x="4389461" y="3137334"/>
+              <a:ext cx="761707" cy="761707"/>
+            </a:xfrm>
+            <a:prstGeom prst="rect">
+              <a:avLst/>
+            </a:prstGeom>
+          </p:spPr>
+        </p:pic>
+        <p:sp>
+          <p:nvSpPr>
+            <p:cNvPr id="5" name="Arrow: Right 4">
+              <a:extLst>
+                <a:ext uri="{FF2B5EF4-FFF2-40B4-BE49-F238E27FC236}">
+                  <a16:creationId xmlns:a16="http://schemas.microsoft.com/office/drawing/2014/main" id="{26086D0D-83EB-DA45-E011-B81684E603D2}"/>
+                </a:ext>
+              </a:extLst>
+            </p:cNvPr>
+            <p:cNvSpPr/>
+            <p:nvPr/>
+          </p:nvSpPr>
+          <p:spPr>
+            <a:xfrm>
+              <a:off x="1786417" y="3933501"/>
+              <a:ext cx="1769518" cy="353083"/>
+            </a:xfrm>
+            <a:prstGeom prst="rightArrow">
+              <a:avLst/>
+            </a:prstGeom>
+            <a:solidFill>
+              <a:srgbClr val="00B1C1"/>
+            </a:solidFill>
+            <a:ln>
+              <a:solidFill>
+                <a:schemeClr val="accent2"/>
+              </a:solidFill>
+            </a:ln>
+          </p:spPr>
+          <p:style>
+            <a:lnRef idx="2">
+              <a:schemeClr val="accent1">
+                <a:shade val="15000"/>
+              </a:schemeClr>
+            </a:lnRef>
+            <a:fillRef idx="1">
+              <a:schemeClr val="accent1"/>
+            </a:fillRef>
+            <a:effectRef idx="0">
+              <a:schemeClr val="accent1"/>
+            </a:effectRef>
+            <a:fontRef idx="minor">
+              <a:schemeClr val="lt1"/>
+            </a:fontRef>
+          </p:style>
+          <p:txBody>
+            <a:bodyPr rtlCol="0" anchor="ctr"/>
+            <a:lstStyle/>
+            <a:p>
+              <a:pPr algn="ctr"/>
+              <a:endParaRPr lang="en-GB"/>
+            </a:p>
+          </p:txBody>
+        </p:sp>
+        <p:sp>
+          <p:nvSpPr>
+            <p:cNvPr id="6" name="Arrow: Right 5">
+              <a:extLst>
+                <a:ext uri="{FF2B5EF4-FFF2-40B4-BE49-F238E27FC236}">
+                  <a16:creationId xmlns:a16="http://schemas.microsoft.com/office/drawing/2014/main" id="{9AEF64BB-2DC7-8F45-A641-2A7A68652985}"/>
+                </a:ext>
+              </a:extLst>
+            </p:cNvPr>
+            <p:cNvSpPr/>
+            <p:nvPr/>
+          </p:nvSpPr>
+          <p:spPr>
+            <a:xfrm>
+              <a:off x="1786417" y="4562234"/>
+              <a:ext cx="3509045" cy="353083"/>
+            </a:xfrm>
+            <a:prstGeom prst="rightArrow">
+              <a:avLst/>
+            </a:prstGeom>
+            <a:solidFill>
+              <a:srgbClr val="00B1C1"/>
+            </a:solidFill>
+            <a:ln>
+              <a:solidFill>
+                <a:schemeClr val="accent4"/>
+              </a:solidFill>
+            </a:ln>
+          </p:spPr>
+          <p:style>
+            <a:lnRef idx="2">
+              <a:schemeClr val="accent1">
+                <a:shade val="15000"/>
+              </a:schemeClr>
+            </a:lnRef>
+            <a:fillRef idx="1">
+              <a:schemeClr val="accent1"/>
+            </a:fillRef>
+            <a:effectRef idx="0">
+              <a:schemeClr val="accent1"/>
+            </a:effectRef>
+            <a:fontRef idx="minor">
+              <a:schemeClr val="lt1"/>
+            </a:fontRef>
+          </p:style>
+          <p:txBody>
+            <a:bodyPr rtlCol="0" anchor="ctr"/>
+            <a:lstStyle/>
+            <a:p>
+              <a:pPr algn="ctr"/>
+              <a:endParaRPr lang="en-GB"/>
+            </a:p>
+          </p:txBody>
+        </p:sp>
+        <p:pic>
+          <p:nvPicPr>
+            <p:cNvPr id="7" name="Graphic 6" descr="Dinosaur Egg with solid fill">
+              <a:extLst>
+                <a:ext uri="{FF2B5EF4-FFF2-40B4-BE49-F238E27FC236}">
+                  <a16:creationId xmlns:a16="http://schemas.microsoft.com/office/drawing/2014/main" id="{7ABC7B40-170E-CEE1-2C3B-BA42A357AFF7}"/>
+                </a:ext>
+              </a:extLst>
+            </p:cNvPr>
+            <p:cNvPicPr>
+              <a:picLocks noChangeAspect="1"/>
+            </p:cNvPicPr>
+            <p:nvPr/>
+          </p:nvPicPr>
+          <p:blipFill>
+            <a:blip>
+              <a:extLst>
+                <a:ext uri="{96DAC541-7B7A-43D3-8B79-37D633B846F1}">
+                  <asvg:svgBlip xmlns:asvg="http://schemas.microsoft.com/office/drawing/2016/SVG/main" r:embed="rId2"/>
+                </a:ext>
+              </a:extLst>
+            </a:blip>
+            <a:srcRect/>
+            <a:stretch/>
+          </p:blipFill>
+          <p:spPr>
+            <a:xfrm>
+              <a:off x="3537520" y="3729188"/>
+              <a:ext cx="761707" cy="761707"/>
+            </a:xfrm>
+            <a:prstGeom prst="rect">
+              <a:avLst/>
+            </a:prstGeom>
+          </p:spPr>
+        </p:pic>
+        <p:pic>
+          <p:nvPicPr>
+            <p:cNvPr id="8" name="Graphic 7" descr="Dinosaur Egg with solid fill">
+              <a:extLst>
+                <a:ext uri="{FF2B5EF4-FFF2-40B4-BE49-F238E27FC236}">
+                  <a16:creationId xmlns:a16="http://schemas.microsoft.com/office/drawing/2014/main" id="{21E36242-97AC-FF6A-5EB1-4AEF7E378246}"/>
+                </a:ext>
+              </a:extLst>
+            </p:cNvPr>
+            <p:cNvPicPr>
+              <a:picLocks noChangeAspect="1"/>
+            </p:cNvPicPr>
+            <p:nvPr/>
+          </p:nvPicPr>
+          <p:blipFill>
+            <a:blip>
+              <a:extLst>
+                <a:ext uri="{96DAC541-7B7A-43D3-8B79-37D633B846F1}">
+                  <asvg:svgBlip xmlns:asvg="http://schemas.microsoft.com/office/drawing/2016/SVG/main" r:embed="rId3"/>
+                </a:ext>
+              </a:extLst>
+            </a:blip>
+            <a:srcRect/>
+            <a:stretch/>
+          </p:blipFill>
+          <p:spPr>
+            <a:xfrm>
+              <a:off x="5288622" y="4317460"/>
+              <a:ext cx="761707" cy="761707"/>
+            </a:xfrm>
+            <a:prstGeom prst="rect">
+              <a:avLst/>
+            </a:prstGeom>
+          </p:spPr>
+        </p:pic>
+        <p:sp>
+          <p:nvSpPr>
+            <p:cNvPr id="9" name="TextBox 8">
+              <a:extLst>
+                <a:ext uri="{FF2B5EF4-FFF2-40B4-BE49-F238E27FC236}">
+                  <a16:creationId xmlns:a16="http://schemas.microsoft.com/office/drawing/2014/main" id="{07F87F1F-1AA3-EE32-9DD8-99475984FFD9}"/>
+                </a:ext>
+              </a:extLst>
+            </p:cNvPr>
+            <p:cNvSpPr txBox="1"/>
+            <p:nvPr/>
+          </p:nvSpPr>
+          <p:spPr>
+            <a:xfrm>
+              <a:off x="1423978" y="2670416"/>
+              <a:ext cx="724878" cy="400110"/>
+            </a:xfrm>
+            <a:prstGeom prst="rect">
+              <a:avLst/>
+            </a:prstGeom>
+            <a:noFill/>
+          </p:spPr>
+          <p:txBody>
+            <a:bodyPr wrap="none" rtlCol="0">
+              <a:spAutoFit/>
+            </a:bodyPr>
+            <a:lstStyle/>
+            <a:p>
+              <a:r>
+                <a:rPr lang="en-GB" sz="2000" dirty="0"/>
+                <a:t>Start</a:t>
+              </a:r>
+            </a:p>
+          </p:txBody>
+        </p:sp>
+        <p:sp>
+          <p:nvSpPr>
+            <p:cNvPr id="10" name="Arrow: Right 9">
+              <a:extLst>
+                <a:ext uri="{FF2B5EF4-FFF2-40B4-BE49-F238E27FC236}">
+                  <a16:creationId xmlns:a16="http://schemas.microsoft.com/office/drawing/2014/main" id="{CA20D2B8-67A0-1BC2-6C37-20543DBACE4D}"/>
+                </a:ext>
+              </a:extLst>
+            </p:cNvPr>
+            <p:cNvSpPr/>
+            <p:nvPr/>
+          </p:nvSpPr>
+          <p:spPr>
+            <a:xfrm>
+              <a:off x="1780171" y="5183729"/>
+              <a:ext cx="2609290" cy="353083"/>
+            </a:xfrm>
+            <a:prstGeom prst="rightArrow">
+              <a:avLst/>
+            </a:prstGeom>
+            <a:solidFill>
+              <a:srgbClr val="00B1C1"/>
+            </a:solidFill>
+            <a:ln>
+              <a:solidFill>
+                <a:schemeClr val="accent4"/>
+              </a:solidFill>
+            </a:ln>
+          </p:spPr>
+          <p:style>
+            <a:lnRef idx="2">
+              <a:schemeClr val="accent1">
+                <a:shade val="15000"/>
+              </a:schemeClr>
+            </a:lnRef>
+            <a:fillRef idx="1">
+              <a:schemeClr val="accent1"/>
+            </a:fillRef>
+            <a:effectRef idx="0">
+              <a:schemeClr val="accent1"/>
+            </a:effectRef>
+            <a:fontRef idx="minor">
+              <a:schemeClr val="lt1"/>
+            </a:fontRef>
+          </p:style>
+          <p:txBody>
+            <a:bodyPr rtlCol="0" anchor="ctr"/>
+            <a:lstStyle/>
+            <a:p>
+              <a:pPr algn="ctr"/>
+              <a:endParaRPr lang="en-GB"/>
+            </a:p>
+          </p:txBody>
+        </p:sp>
+        <p:pic>
+          <p:nvPicPr>
+            <p:cNvPr id="11" name="Graphic 10" descr="Dinosaur Egg with solid fill">
+              <a:extLst>
+                <a:ext uri="{FF2B5EF4-FFF2-40B4-BE49-F238E27FC236}">
+                  <a16:creationId xmlns:a16="http://schemas.microsoft.com/office/drawing/2014/main" id="{C7431277-B5A4-58E7-D59F-09DA0AE7308A}"/>
+                </a:ext>
+              </a:extLst>
+            </p:cNvPr>
+            <p:cNvPicPr>
+              <a:picLocks noChangeAspect="1"/>
+            </p:cNvPicPr>
+            <p:nvPr/>
+          </p:nvPicPr>
+          <p:blipFill>
+            <a:blip>
+              <a:extLst>
+                <a:ext uri="{96DAC541-7B7A-43D3-8B79-37D633B846F1}">
+                  <asvg:svgBlip xmlns:asvg="http://schemas.microsoft.com/office/drawing/2016/SVG/main" r:embed="rId3"/>
+                </a:ext>
+              </a:extLst>
+            </a:blip>
+            <a:srcRect/>
+            <a:stretch/>
+          </p:blipFill>
+          <p:spPr>
+            <a:xfrm>
+              <a:off x="4365275" y="4957378"/>
+              <a:ext cx="761707" cy="761707"/>
+            </a:xfrm>
+            <a:prstGeom prst="rect">
+              <a:avLst/>
+            </a:prstGeom>
+          </p:spPr>
+        </p:pic>
+        <p:cxnSp>
+          <p:nvCxnSpPr>
+            <p:cNvPr id="12" name="Straight Connector 11">
+              <a:extLst>
+                <a:ext uri="{FF2B5EF4-FFF2-40B4-BE49-F238E27FC236}">
+                  <a16:creationId xmlns:a16="http://schemas.microsoft.com/office/drawing/2014/main" id="{030F414D-7C21-8431-DA22-516F3068B7E1}"/>
+                </a:ext>
+              </a:extLst>
+            </p:cNvPr>
+            <p:cNvCxnSpPr>
+              <a:cxnSpLocks/>
+            </p:cNvCxnSpPr>
+            <p:nvPr/>
+          </p:nvCxnSpPr>
+          <p:spPr>
+            <a:xfrm>
+              <a:off x="1786417" y="3166565"/>
+              <a:ext cx="0" cy="2515693"/>
+            </a:xfrm>
+            <a:prstGeom prst="line">
+              <a:avLst/>
+            </a:prstGeom>
+            <a:ln w="38100">
+              <a:solidFill>
+                <a:schemeClr val="tx1"/>
+              </a:solidFill>
+              <a:prstDash val="solid"/>
+            </a:ln>
+          </p:spPr>
+          <p:style>
+            <a:lnRef idx="1">
+              <a:schemeClr val="accent1"/>
+            </a:lnRef>
+            <a:fillRef idx="0">
+              <a:schemeClr val="accent1"/>
+            </a:fillRef>
+            <a:effectRef idx="0">
+              <a:schemeClr val="accent1"/>
+            </a:effectRef>
+            <a:fontRef idx="minor">
+              <a:schemeClr val="tx1"/>
+            </a:fontRef>
+          </p:style>
+        </p:cxnSp>
+      </p:grpSp>
+      <p:pic>
+        <p:nvPicPr>
+          <p:cNvPr id="13" name="Graphic 12" descr="Office worker female with solid fill">
+            <a:extLst>
+              <a:ext uri="{FF2B5EF4-FFF2-40B4-BE49-F238E27FC236}">
+                <a16:creationId xmlns:a16="http://schemas.microsoft.com/office/drawing/2014/main" id="{6B9E55EE-CF06-2E5A-8867-3E1D3C4221B1}"/>
+              </a:ext>
+            </a:extLst>
+          </p:cNvPr>
+          <p:cNvPicPr>
+            <a:picLocks noChangeAspect="1"/>
+          </p:cNvPicPr>
+          <p:nvPr/>
+        </p:nvPicPr>
+        <p:blipFill>
+          <a:blip>
+            <a:extLst>
+              <a:ext uri="{96DAC541-7B7A-43D3-8B79-37D633B846F1}">
+                <asvg:svgBlip xmlns:asvg="http://schemas.microsoft.com/office/drawing/2016/SVG/main" r:embed="rId4"/>
+              </a:ext>
+            </a:extLst>
+          </a:blip>
+          <a:srcRect/>
+          <a:stretch/>
+        </p:blipFill>
+        <p:spPr>
+          <a:xfrm>
+            <a:off x="692763" y="1630444"/>
+            <a:ext cx="767238" cy="767238"/>
+          </a:xfrm>
+          <a:prstGeom prst="rect">
+            <a:avLst/>
+          </a:prstGeom>
+        </p:spPr>
+      </p:pic>
+      <p:pic>
+        <p:nvPicPr>
+          <p:cNvPr id="15" name="Graphic 14" descr="Office worker female with solid fill">
+            <a:extLst>
+              <a:ext uri="{FF2B5EF4-FFF2-40B4-BE49-F238E27FC236}">
+                <a16:creationId xmlns:a16="http://schemas.microsoft.com/office/drawing/2014/main" id="{CDF8E448-C389-EAFE-997D-292AC5372C78}"/>
+              </a:ext>
+            </a:extLst>
+          </p:cNvPr>
+          <p:cNvPicPr>
+            <a:picLocks noChangeAspect="1"/>
+          </p:cNvPicPr>
+          <p:nvPr/>
+        </p:nvPicPr>
+        <p:blipFill>
+          <a:blip>
+            <a:extLst>
+              <a:ext uri="{96DAC541-7B7A-43D3-8B79-37D633B846F1}">
+                <asvg:svgBlip xmlns:asvg="http://schemas.microsoft.com/office/drawing/2016/SVG/main" r:embed="rId5"/>
+              </a:ext>
+            </a:extLst>
+          </a:blip>
+          <a:srcRect/>
+          <a:stretch/>
+        </p:blipFill>
+        <p:spPr>
+          <a:xfrm>
+            <a:off x="686517" y="2968767"/>
+            <a:ext cx="767238" cy="767238"/>
+          </a:xfrm>
+          <a:prstGeom prst="rect">
+            <a:avLst/>
+          </a:prstGeom>
+        </p:spPr>
+      </p:pic>
+      <p:grpSp>
+        <p:nvGrpSpPr>
+          <p:cNvPr id="16" name="Group 15">
+            <a:extLst>
+              <a:ext uri="{FF2B5EF4-FFF2-40B4-BE49-F238E27FC236}">
+                <a16:creationId xmlns:a16="http://schemas.microsoft.com/office/drawing/2014/main" id="{D10CE0F5-FA86-A2D8-6115-156552C101F4}"/>
+              </a:ext>
+            </a:extLst>
+          </p:cNvPr>
+          <p:cNvGrpSpPr/>
+          <p:nvPr/>
+        </p:nvGrpSpPr>
+        <p:grpSpPr>
+          <a:xfrm>
+            <a:off x="6622957" y="929432"/>
+            <a:ext cx="4626349" cy="3060861"/>
+            <a:chOff x="1423978" y="2670416"/>
+            <a:chExt cx="4626349" cy="3060861"/>
+          </a:xfrm>
+        </p:grpSpPr>
+        <p:sp>
+          <p:nvSpPr>
+            <p:cNvPr id="17" name="Arrow: Right 16">
+              <a:extLst>
+                <a:ext uri="{FF2B5EF4-FFF2-40B4-BE49-F238E27FC236}">
+                  <a16:creationId xmlns:a16="http://schemas.microsoft.com/office/drawing/2014/main" id="{84A1E183-54CF-1023-7FF1-0CF1DE5D5297}"/>
+                </a:ext>
+              </a:extLst>
+            </p:cNvPr>
+            <p:cNvSpPr/>
+            <p:nvPr/>
+          </p:nvSpPr>
+          <p:spPr>
+            <a:xfrm>
+              <a:off x="1786417" y="3344858"/>
+              <a:ext cx="2609290" cy="353083"/>
+            </a:xfrm>
+            <a:prstGeom prst="rightArrow">
+              <a:avLst/>
+            </a:prstGeom>
+            <a:solidFill>
+              <a:srgbClr val="00B1C1"/>
+            </a:solidFill>
+            <a:ln>
+              <a:solidFill>
+                <a:schemeClr val="accent2"/>
+              </a:solidFill>
+            </a:ln>
+          </p:spPr>
+          <p:style>
+            <a:lnRef idx="2">
+              <a:schemeClr val="accent1">
+                <a:shade val="15000"/>
+              </a:schemeClr>
+            </a:lnRef>
+            <a:fillRef idx="1">
+              <a:schemeClr val="accent1"/>
+            </a:fillRef>
+            <a:effectRef idx="0">
+              <a:schemeClr val="accent1"/>
+            </a:effectRef>
+            <a:fontRef idx="minor">
+              <a:schemeClr val="lt1"/>
+            </a:fontRef>
+          </p:style>
+          <p:txBody>
+            <a:bodyPr rtlCol="0" anchor="ctr"/>
+            <a:lstStyle/>
+            <a:p>
+              <a:pPr algn="ctr"/>
+              <a:endParaRPr lang="en-GB"/>
+            </a:p>
+          </p:txBody>
+        </p:sp>
+        <p:pic>
+          <p:nvPicPr>
+            <p:cNvPr id="18" name="Graphic 17" descr="Dinosaur Egg with solid fill">
+              <a:extLst>
+                <a:ext uri="{FF2B5EF4-FFF2-40B4-BE49-F238E27FC236}">
+                  <a16:creationId xmlns:a16="http://schemas.microsoft.com/office/drawing/2014/main" id="{DDF3C648-4ECE-D77F-37D6-6696AAAC302E}"/>
+                </a:ext>
+              </a:extLst>
+            </p:cNvPr>
+            <p:cNvPicPr>
+              <a:picLocks noChangeAspect="1"/>
+            </p:cNvPicPr>
+            <p:nvPr/>
+          </p:nvPicPr>
+          <p:blipFill>
+            <a:blip>
+              <a:extLst>
+                <a:ext uri="{96DAC541-7B7A-43D3-8B79-37D633B846F1}">
+                  <asvg:svgBlip xmlns:asvg="http://schemas.microsoft.com/office/drawing/2016/SVG/main" r:embed="rId2"/>
+                </a:ext>
+              </a:extLst>
+            </a:blip>
+            <a:srcRect/>
+            <a:stretch/>
+          </p:blipFill>
+          <p:spPr>
+            <a:xfrm>
+              <a:off x="4386499" y="3140442"/>
+              <a:ext cx="761707" cy="761707"/>
+            </a:xfrm>
+            <a:prstGeom prst="rect">
+              <a:avLst/>
+            </a:prstGeom>
+          </p:spPr>
+        </p:pic>
+        <p:sp>
+          <p:nvSpPr>
+            <p:cNvPr id="19" name="Arrow: Right 18">
+              <a:extLst>
+                <a:ext uri="{FF2B5EF4-FFF2-40B4-BE49-F238E27FC236}">
+                  <a16:creationId xmlns:a16="http://schemas.microsoft.com/office/drawing/2014/main" id="{1C918828-B16B-1201-4A52-4841CF42E1AE}"/>
+                </a:ext>
+              </a:extLst>
+            </p:cNvPr>
+            <p:cNvSpPr/>
+            <p:nvPr/>
+          </p:nvSpPr>
+          <p:spPr>
+            <a:xfrm>
+              <a:off x="1786417" y="3933501"/>
+              <a:ext cx="1769518" cy="353083"/>
+            </a:xfrm>
+            <a:prstGeom prst="rightArrow">
+              <a:avLst/>
+            </a:prstGeom>
+            <a:solidFill>
+              <a:schemeClr val="accent6"/>
+            </a:solidFill>
+            <a:ln>
+              <a:solidFill>
+                <a:schemeClr val="accent5"/>
+              </a:solidFill>
+            </a:ln>
+          </p:spPr>
+          <p:style>
+            <a:lnRef idx="2">
+              <a:schemeClr val="accent1">
+                <a:shade val="15000"/>
+              </a:schemeClr>
+            </a:lnRef>
+            <a:fillRef idx="1">
+              <a:schemeClr val="accent1"/>
+            </a:fillRef>
+            <a:effectRef idx="0">
+              <a:schemeClr val="accent1"/>
+            </a:effectRef>
+            <a:fontRef idx="minor">
+              <a:schemeClr val="lt1"/>
+            </a:fontRef>
+          </p:style>
+          <p:txBody>
+            <a:bodyPr rtlCol="0" anchor="ctr"/>
+            <a:lstStyle/>
+            <a:p>
+              <a:pPr algn="ctr"/>
+              <a:endParaRPr lang="en-GB"/>
+            </a:p>
+          </p:txBody>
+        </p:sp>
+        <p:sp>
+          <p:nvSpPr>
+            <p:cNvPr id="20" name="Arrow: Right 19">
+              <a:extLst>
+                <a:ext uri="{FF2B5EF4-FFF2-40B4-BE49-F238E27FC236}">
+                  <a16:creationId xmlns:a16="http://schemas.microsoft.com/office/drawing/2014/main" id="{27ED4DB2-0E50-B2A8-E184-40FAF71F9F0B}"/>
+                </a:ext>
+              </a:extLst>
+            </p:cNvPr>
+            <p:cNvSpPr/>
+            <p:nvPr/>
+          </p:nvSpPr>
+          <p:spPr>
+            <a:xfrm>
+              <a:off x="1786417" y="4562234"/>
+              <a:ext cx="3509045" cy="353083"/>
+            </a:xfrm>
+            <a:prstGeom prst="rightArrow">
+              <a:avLst/>
+            </a:prstGeom>
+            <a:solidFill>
+              <a:srgbClr val="00B1C1"/>
+            </a:solidFill>
+            <a:ln>
+              <a:solidFill>
+                <a:schemeClr val="accent4"/>
+              </a:solidFill>
+            </a:ln>
+          </p:spPr>
+          <p:style>
+            <a:lnRef idx="2">
+              <a:schemeClr val="accent1">
+                <a:shade val="15000"/>
+              </a:schemeClr>
+            </a:lnRef>
+            <a:fillRef idx="1">
+              <a:schemeClr val="accent1"/>
+            </a:fillRef>
+            <a:effectRef idx="0">
+              <a:schemeClr val="accent1"/>
+            </a:effectRef>
+            <a:fontRef idx="minor">
+              <a:schemeClr val="lt1"/>
+            </a:fontRef>
+          </p:style>
+          <p:txBody>
+            <a:bodyPr rtlCol="0" anchor="ctr"/>
+            <a:lstStyle/>
+            <a:p>
+              <a:pPr algn="ctr"/>
+              <a:endParaRPr lang="en-GB"/>
+            </a:p>
+          </p:txBody>
+        </p:sp>
+        <p:pic>
+          <p:nvPicPr>
+            <p:cNvPr id="21" name="Graphic 20" descr="Dinosaur Egg with solid fill">
+              <a:extLst>
+                <a:ext uri="{FF2B5EF4-FFF2-40B4-BE49-F238E27FC236}">
+                  <a16:creationId xmlns:a16="http://schemas.microsoft.com/office/drawing/2014/main" id="{40EB682A-8562-698D-2160-C83119AB7C83}"/>
+                </a:ext>
+              </a:extLst>
+            </p:cNvPr>
+            <p:cNvPicPr>
+              <a:picLocks noChangeAspect="1"/>
+            </p:cNvPicPr>
+            <p:nvPr/>
+          </p:nvPicPr>
+          <p:blipFill>
+            <a:blip>
+              <a:extLst>
+                <a:ext uri="{96DAC541-7B7A-43D3-8B79-37D633B846F1}">
+                  <asvg:svgBlip xmlns:asvg="http://schemas.microsoft.com/office/drawing/2016/SVG/main" r:embed="rId6"/>
+                </a:ext>
+              </a:extLst>
+            </a:blip>
+            <a:srcRect/>
+            <a:stretch/>
+          </p:blipFill>
+          <p:spPr>
+            <a:xfrm>
+              <a:off x="3537519" y="3746274"/>
+              <a:ext cx="761707" cy="761707"/>
+            </a:xfrm>
+            <a:prstGeom prst="rect">
+              <a:avLst/>
+            </a:prstGeom>
+          </p:spPr>
+        </p:pic>
+        <p:pic>
+          <p:nvPicPr>
+            <p:cNvPr id="22" name="Graphic 21" descr="Dinosaur Egg with solid fill">
+              <a:extLst>
+                <a:ext uri="{FF2B5EF4-FFF2-40B4-BE49-F238E27FC236}">
+                  <a16:creationId xmlns:a16="http://schemas.microsoft.com/office/drawing/2014/main" id="{E3959C91-7C08-87A6-B8F8-191D9F4C1C1D}"/>
+                </a:ext>
+              </a:extLst>
+            </p:cNvPr>
+            <p:cNvPicPr>
+              <a:picLocks noChangeAspect="1"/>
+            </p:cNvPicPr>
+            <p:nvPr/>
+          </p:nvPicPr>
+          <p:blipFill>
+            <a:blip>
+              <a:extLst>
+                <a:ext uri="{96DAC541-7B7A-43D3-8B79-37D633B846F1}">
+                  <asvg:svgBlip xmlns:asvg="http://schemas.microsoft.com/office/drawing/2016/SVG/main" r:embed="rId3"/>
+                </a:ext>
+              </a:extLst>
+            </a:blip>
+            <a:srcRect/>
+            <a:stretch/>
+          </p:blipFill>
+          <p:spPr>
+            <a:xfrm>
+              <a:off x="5288620" y="4324844"/>
+              <a:ext cx="761707" cy="761707"/>
+            </a:xfrm>
+            <a:prstGeom prst="rect">
+              <a:avLst/>
+            </a:prstGeom>
+          </p:spPr>
+        </p:pic>
+        <p:sp>
+          <p:nvSpPr>
+            <p:cNvPr id="23" name="TextBox 22">
+              <a:extLst>
+                <a:ext uri="{FF2B5EF4-FFF2-40B4-BE49-F238E27FC236}">
+                  <a16:creationId xmlns:a16="http://schemas.microsoft.com/office/drawing/2014/main" id="{A19C0B26-5EAE-8DA5-1C13-E3AC31458453}"/>
+                </a:ext>
+              </a:extLst>
+            </p:cNvPr>
+            <p:cNvSpPr txBox="1"/>
+            <p:nvPr/>
+          </p:nvSpPr>
+          <p:spPr>
+            <a:xfrm>
+              <a:off x="1423978" y="2670416"/>
+              <a:ext cx="724878" cy="400110"/>
+            </a:xfrm>
+            <a:prstGeom prst="rect">
+              <a:avLst/>
+            </a:prstGeom>
+            <a:noFill/>
+          </p:spPr>
+          <p:txBody>
+            <a:bodyPr wrap="none" rtlCol="0">
+              <a:spAutoFit/>
+            </a:bodyPr>
+            <a:lstStyle/>
+            <a:p>
+              <a:r>
+                <a:rPr lang="en-GB" sz="2000" dirty="0"/>
+                <a:t>Start</a:t>
+              </a:r>
+            </a:p>
+          </p:txBody>
+        </p:sp>
+        <p:sp>
+          <p:nvSpPr>
+            <p:cNvPr id="24" name="Arrow: Right 23">
+              <a:extLst>
+                <a:ext uri="{FF2B5EF4-FFF2-40B4-BE49-F238E27FC236}">
+                  <a16:creationId xmlns:a16="http://schemas.microsoft.com/office/drawing/2014/main" id="{F46BB749-7280-1D94-3CFD-AC62EEDBC974}"/>
+                </a:ext>
+              </a:extLst>
+            </p:cNvPr>
+            <p:cNvSpPr/>
+            <p:nvPr/>
+          </p:nvSpPr>
+          <p:spPr>
+            <a:xfrm>
+              <a:off x="1780171" y="5183729"/>
+              <a:ext cx="2609290" cy="353083"/>
+            </a:xfrm>
+            <a:prstGeom prst="rightArrow">
+              <a:avLst/>
+            </a:prstGeom>
+            <a:solidFill>
+              <a:srgbClr val="00B1C1"/>
+            </a:solidFill>
+            <a:ln>
+              <a:solidFill>
+                <a:schemeClr val="accent1"/>
+              </a:solidFill>
+            </a:ln>
+          </p:spPr>
+          <p:style>
+            <a:lnRef idx="2">
+              <a:schemeClr val="accent1">
+                <a:shade val="15000"/>
+              </a:schemeClr>
+            </a:lnRef>
+            <a:fillRef idx="1">
+              <a:schemeClr val="accent1"/>
+            </a:fillRef>
+            <a:effectRef idx="0">
+              <a:schemeClr val="accent1"/>
+            </a:effectRef>
+            <a:fontRef idx="minor">
+              <a:schemeClr val="lt1"/>
+            </a:fontRef>
+          </p:style>
+          <p:txBody>
+            <a:bodyPr rtlCol="0" anchor="ctr"/>
+            <a:lstStyle/>
+            <a:p>
+              <a:pPr algn="ctr"/>
+              <a:endParaRPr lang="en-GB"/>
+            </a:p>
+          </p:txBody>
+        </p:sp>
+        <p:pic>
+          <p:nvPicPr>
+            <p:cNvPr id="25" name="Graphic 24" descr="Dinosaur Egg with solid fill">
+              <a:extLst>
+                <a:ext uri="{FF2B5EF4-FFF2-40B4-BE49-F238E27FC236}">
+                  <a16:creationId xmlns:a16="http://schemas.microsoft.com/office/drawing/2014/main" id="{E7884ABB-B84F-13AD-1D14-79C686A533FE}"/>
+                </a:ext>
+              </a:extLst>
+            </p:cNvPr>
+            <p:cNvPicPr>
+              <a:picLocks noChangeAspect="1"/>
+            </p:cNvPicPr>
+            <p:nvPr/>
+          </p:nvPicPr>
+          <p:blipFill>
+            <a:blip>
+              <a:extLst>
+                <a:ext uri="{96DAC541-7B7A-43D3-8B79-37D633B846F1}">
+                  <asvg:svgBlip xmlns:asvg="http://schemas.microsoft.com/office/drawing/2016/SVG/main" r:embed="rId7"/>
+                </a:ext>
+              </a:extLst>
+            </a:blip>
+            <a:srcRect/>
+            <a:stretch/>
+          </p:blipFill>
+          <p:spPr>
+            <a:xfrm>
+              <a:off x="4381035" y="4969570"/>
+              <a:ext cx="761707" cy="761707"/>
+            </a:xfrm>
+            <a:prstGeom prst="rect">
+              <a:avLst/>
+            </a:prstGeom>
+          </p:spPr>
+        </p:pic>
+        <p:cxnSp>
+          <p:nvCxnSpPr>
+            <p:cNvPr id="26" name="Straight Connector 25">
+              <a:extLst>
+                <a:ext uri="{FF2B5EF4-FFF2-40B4-BE49-F238E27FC236}">
+                  <a16:creationId xmlns:a16="http://schemas.microsoft.com/office/drawing/2014/main" id="{9398D570-272F-B063-D570-A2908B2CFFD8}"/>
+                </a:ext>
+              </a:extLst>
+            </p:cNvPr>
+            <p:cNvCxnSpPr>
+              <a:cxnSpLocks/>
+            </p:cNvCxnSpPr>
+            <p:nvPr/>
+          </p:nvCxnSpPr>
+          <p:spPr>
+            <a:xfrm>
+              <a:off x="1786417" y="3166565"/>
+              <a:ext cx="0" cy="2515693"/>
+            </a:xfrm>
+            <a:prstGeom prst="line">
+              <a:avLst/>
+            </a:prstGeom>
+            <a:ln w="38100">
+              <a:solidFill>
+                <a:schemeClr val="tx1"/>
+              </a:solidFill>
+              <a:prstDash val="solid"/>
+            </a:ln>
+          </p:spPr>
+          <p:style>
+            <a:lnRef idx="1">
+              <a:schemeClr val="accent1"/>
+            </a:lnRef>
+            <a:fillRef idx="0">
+              <a:schemeClr val="accent1"/>
+            </a:fillRef>
+            <a:effectRef idx="0">
+              <a:schemeClr val="accent1"/>
+            </a:effectRef>
+            <a:fontRef idx="minor">
+              <a:schemeClr val="tx1"/>
+            </a:fontRef>
+          </p:style>
+        </p:cxnSp>
+      </p:grpSp>
+      <p:pic>
+        <p:nvPicPr>
+          <p:cNvPr id="31" name="Picture 30">
+            <a:extLst>
+              <a:ext uri="{FF2B5EF4-FFF2-40B4-BE49-F238E27FC236}">
+                <a16:creationId xmlns:a16="http://schemas.microsoft.com/office/drawing/2014/main" id="{284ABD75-21C2-223E-04AD-F2AC83946455}"/>
+              </a:ext>
+            </a:extLst>
+          </p:cNvPr>
+          <p:cNvPicPr>
+            <a:picLocks noChangeAspect="1"/>
+          </p:cNvPicPr>
+          <p:nvPr/>
+        </p:nvPicPr>
+        <p:blipFill>
+          <a:blip r:embed="rId8">
+            <a:duotone>
+              <a:schemeClr val="accent2">
+                <a:shade val="45000"/>
+                <a:satMod val="135000"/>
+              </a:schemeClr>
+              <a:prstClr val="white"/>
+            </a:duotone>
+          </a:blip>
+          <a:stretch>
+            <a:fillRect/>
+          </a:stretch>
+        </p:blipFill>
+        <p:spPr>
+          <a:xfrm>
+            <a:off x="561516" y="1573848"/>
+            <a:ext cx="873016" cy="873016"/>
+          </a:xfrm>
+          <a:prstGeom prst="rect">
+            <a:avLst/>
+          </a:prstGeom>
+        </p:spPr>
+      </p:pic>
+      <p:pic>
+        <p:nvPicPr>
+          <p:cNvPr id="33" name="Picture 32">
+            <a:extLst>
+              <a:ext uri="{FF2B5EF4-FFF2-40B4-BE49-F238E27FC236}">
+                <a16:creationId xmlns:a16="http://schemas.microsoft.com/office/drawing/2014/main" id="{0780BDD7-45A0-E841-2082-6C431C590DEF}"/>
+              </a:ext>
+            </a:extLst>
+          </p:cNvPr>
+          <p:cNvPicPr>
+            <a:picLocks noChangeAspect="1"/>
+          </p:cNvPicPr>
+          <p:nvPr/>
+        </p:nvPicPr>
+        <p:blipFill>
+          <a:blip r:embed="rId8">
+            <a:duotone>
+              <a:schemeClr val="accent4">
+                <a:shade val="45000"/>
+                <a:satMod val="135000"/>
+              </a:schemeClr>
+              <a:prstClr val="white"/>
+            </a:duotone>
+          </a:blip>
+          <a:stretch>
+            <a:fillRect/>
+          </a:stretch>
+        </p:blipFill>
+        <p:spPr>
+          <a:xfrm>
+            <a:off x="561516" y="2831229"/>
+            <a:ext cx="873016" cy="873016"/>
+          </a:xfrm>
+          <a:prstGeom prst="rect">
+            <a:avLst/>
+          </a:prstGeom>
+        </p:spPr>
+      </p:pic>
+      <p:pic>
+        <p:nvPicPr>
+          <p:cNvPr id="37" name="Picture 36">
+            <a:extLst>
+              <a:ext uri="{FF2B5EF4-FFF2-40B4-BE49-F238E27FC236}">
+                <a16:creationId xmlns:a16="http://schemas.microsoft.com/office/drawing/2014/main" id="{F822FE67-6C00-A405-5460-E5D7537D7AC9}"/>
+              </a:ext>
+            </a:extLst>
+          </p:cNvPr>
+          <p:cNvPicPr>
+            <a:picLocks noChangeAspect="1"/>
+          </p:cNvPicPr>
+          <p:nvPr/>
+        </p:nvPicPr>
+        <p:blipFill>
+          <a:blip r:embed="rId8">
+            <a:duotone>
+              <a:schemeClr val="accent2">
+                <a:shade val="45000"/>
+                <a:satMod val="135000"/>
+              </a:schemeClr>
+              <a:prstClr val="white"/>
+            </a:duotone>
+          </a:blip>
+          <a:stretch>
+            <a:fillRect/>
+          </a:stretch>
+        </p:blipFill>
+        <p:spPr>
+          <a:xfrm>
+            <a:off x="6220728" y="1419029"/>
+            <a:ext cx="684000" cy="684000"/>
+          </a:xfrm>
+          <a:prstGeom prst="rect">
+            <a:avLst/>
+          </a:prstGeom>
+        </p:spPr>
+      </p:pic>
+      <p:pic>
+        <p:nvPicPr>
+          <p:cNvPr id="39" name="Picture 38">
+            <a:extLst>
+              <a:ext uri="{FF2B5EF4-FFF2-40B4-BE49-F238E27FC236}">
+                <a16:creationId xmlns:a16="http://schemas.microsoft.com/office/drawing/2014/main" id="{A8A01869-C578-1AC5-A9E4-E634184628B2}"/>
+              </a:ext>
+            </a:extLst>
+          </p:cNvPr>
+          <p:cNvPicPr>
+            <a:picLocks noChangeAspect="1"/>
+          </p:cNvPicPr>
+          <p:nvPr/>
+        </p:nvPicPr>
+        <p:blipFill>
+          <a:blip r:embed="rId8">
+            <a:duotone>
+              <a:schemeClr val="accent4">
+                <a:shade val="45000"/>
+                <a:satMod val="135000"/>
+              </a:schemeClr>
+              <a:prstClr val="white"/>
+            </a:duotone>
+          </a:blip>
+          <a:stretch>
+            <a:fillRect/>
+          </a:stretch>
+        </p:blipFill>
+        <p:spPr>
+          <a:xfrm>
+            <a:off x="6212300" y="2629367"/>
+            <a:ext cx="684000" cy="684000"/>
+          </a:xfrm>
+          <a:prstGeom prst="rect">
+            <a:avLst/>
+          </a:prstGeom>
+        </p:spPr>
+      </p:pic>
+      <p:pic>
+        <p:nvPicPr>
+          <p:cNvPr id="41" name="Picture 40">
+            <a:extLst>
+              <a:ext uri="{FF2B5EF4-FFF2-40B4-BE49-F238E27FC236}">
+                <a16:creationId xmlns:a16="http://schemas.microsoft.com/office/drawing/2014/main" id="{032A94E8-1DB4-A1D8-9FDF-B35341DA2EBD}"/>
+              </a:ext>
+            </a:extLst>
+          </p:cNvPr>
+          <p:cNvPicPr>
+            <a:picLocks noChangeAspect="1"/>
+          </p:cNvPicPr>
+          <p:nvPr/>
+        </p:nvPicPr>
+        <p:blipFill>
+          <a:blip r:embed="rId8">
+            <a:duotone>
+              <a:schemeClr val="accent5">
+                <a:shade val="45000"/>
+                <a:satMod val="135000"/>
+              </a:schemeClr>
+              <a:prstClr val="white"/>
+            </a:duotone>
+          </a:blip>
+          <a:stretch>
+            <a:fillRect/>
+          </a:stretch>
+        </p:blipFill>
+        <p:spPr>
+          <a:xfrm>
+            <a:off x="6222066" y="2021818"/>
+            <a:ext cx="684000" cy="684000"/>
+          </a:xfrm>
+          <a:prstGeom prst="rect">
+            <a:avLst/>
+          </a:prstGeom>
+        </p:spPr>
+      </p:pic>
+      <p:pic>
+        <p:nvPicPr>
+          <p:cNvPr id="43" name="Picture 42">
+            <a:extLst>
+              <a:ext uri="{FF2B5EF4-FFF2-40B4-BE49-F238E27FC236}">
+                <a16:creationId xmlns:a16="http://schemas.microsoft.com/office/drawing/2014/main" id="{369D3221-DC36-099A-6F56-D96B32825DBA}"/>
+              </a:ext>
+            </a:extLst>
+          </p:cNvPr>
+          <p:cNvPicPr>
+            <a:picLocks noChangeAspect="1"/>
+          </p:cNvPicPr>
+          <p:nvPr/>
+        </p:nvPicPr>
+        <p:blipFill>
+          <a:blip r:embed="rId8">
+            <a:duotone>
+              <a:schemeClr val="accent1">
+                <a:shade val="45000"/>
+                <a:satMod val="135000"/>
+              </a:schemeClr>
+              <a:prstClr val="white"/>
+            </a:duotone>
+          </a:blip>
+          <a:stretch>
+            <a:fillRect/>
+          </a:stretch>
+        </p:blipFill>
+        <p:spPr>
+          <a:xfrm>
+            <a:off x="6212300" y="3278329"/>
+            <a:ext cx="684000" cy="684000"/>
+          </a:xfrm>
+          <a:prstGeom prst="rect">
+            <a:avLst/>
+          </a:prstGeom>
+        </p:spPr>
+      </p:pic>
+    </p:spTree>
+    <p:extLst>
+      <p:ext uri="{BB962C8B-B14F-4D97-AF65-F5344CB8AC3E}">
+        <p14:creationId xmlns:p14="http://schemas.microsoft.com/office/powerpoint/2010/main" val="1111756172"/>
+      </p:ext>
+    </p:extLst>
+  </p:cSld>
+  <p:clrMapOvr>
+    <a:masterClrMapping/>
+  </p:clrMapOvr>
+</p:sld>
+</file>
+
+<file path=ppt/slides/slide8.xml><?xml version="1.0" encoding="utf-8"?>
+<p:sld xmlns:a="http://schemas.openxmlformats.org/drawingml/2006/main" xmlns:r="http://schemas.openxmlformats.org/officeDocument/2006/relationships" xmlns:p="http://schemas.openxmlformats.org/presentationml/2006/main">
+  <p:cSld>
+    <p:spTree>
+      <p:nvGrpSpPr>
+        <p:cNvPr id="1" name="">
+          <a:extLst>
+            <a:ext uri="{FF2B5EF4-FFF2-40B4-BE49-F238E27FC236}">
+              <a16:creationId xmlns:a16="http://schemas.microsoft.com/office/drawing/2014/main" id="{3F881903-FF22-7B00-8257-BC3577DBFE9B}"/>
+            </a:ext>
+          </a:extLst>
+        </p:cNvPr>
+        <p:cNvGrpSpPr/>
+        <p:nvPr/>
+      </p:nvGrpSpPr>
+      <p:grpSpPr>
+        <a:xfrm>
+          <a:off x="0" y="0"/>
+          <a:ext cx="0" cy="0"/>
+          <a:chOff x="0" y="0"/>
+          <a:chExt cx="0" cy="0"/>
+        </a:xfrm>
+      </p:grpSpPr>
+      <p:sp>
+        <p:nvSpPr>
+          <p:cNvPr id="45" name="Rectangle 44">
+            <a:extLst>
+              <a:ext uri="{FF2B5EF4-FFF2-40B4-BE49-F238E27FC236}">
+                <a16:creationId xmlns:a16="http://schemas.microsoft.com/office/drawing/2014/main" id="{A3093B17-8667-1FCF-590E-5E4DB7B42477}"/>
+              </a:ext>
+            </a:extLst>
+          </p:cNvPr>
+          <p:cNvSpPr/>
+          <p:nvPr/>
+        </p:nvSpPr>
+        <p:spPr>
+          <a:xfrm>
+            <a:off x="629306" y="796157"/>
+            <a:ext cx="10620000" cy="4457969"/>
+          </a:xfrm>
+          <a:prstGeom prst="rect">
+            <a:avLst/>
+          </a:prstGeom>
+          <a:solidFill>
+            <a:schemeClr val="bg1"/>
+          </a:solidFill>
+          <a:ln>
+            <a:noFill/>
+          </a:ln>
+        </p:spPr>
+        <p:style>
+          <a:lnRef idx="2">
+            <a:schemeClr val="accent1">
+              <a:shade val="15000"/>
+            </a:schemeClr>
+          </a:lnRef>
+          <a:fillRef idx="1">
+            <a:schemeClr val="accent1"/>
+          </a:fillRef>
+          <a:effectRef idx="0">
+            <a:schemeClr val="accent1"/>
+          </a:effectRef>
+          <a:fontRef idx="minor">
+            <a:schemeClr val="lt1"/>
+          </a:fontRef>
+        </p:style>
+        <p:txBody>
+          <a:bodyPr rtlCol="0" anchor="ctr"/>
+          <a:lstStyle/>
+          <a:p>
+            <a:pPr algn="ctr"/>
+            <a:endParaRPr lang="en-GB" dirty="0"/>
+          </a:p>
+        </p:txBody>
+      </p:sp>
+      <p:sp>
+        <p:nvSpPr>
+          <p:cNvPr id="34" name="Rectangle 33">
+            <a:extLst>
+              <a:ext uri="{FF2B5EF4-FFF2-40B4-BE49-F238E27FC236}">
+                <a16:creationId xmlns:a16="http://schemas.microsoft.com/office/drawing/2014/main" id="{B298B3D1-D4AF-5CFD-C88D-3E4B8542A0A7}"/>
+              </a:ext>
+            </a:extLst>
+          </p:cNvPr>
+          <p:cNvSpPr/>
+          <p:nvPr/>
+        </p:nvSpPr>
+        <p:spPr>
+          <a:xfrm>
+            <a:off x="1528874" y="4122026"/>
+            <a:ext cx="3509045" cy="190375"/>
+          </a:xfrm>
+          <a:prstGeom prst="rect">
+            <a:avLst/>
+          </a:prstGeom>
+          <a:solidFill>
+            <a:srgbClr val="00B1C1"/>
+          </a:solidFill>
+          <a:ln>
+            <a:solidFill>
+              <a:schemeClr val="accent3"/>
+            </a:solidFill>
+          </a:ln>
+        </p:spPr>
+        <p:style>
+          <a:lnRef idx="2">
+            <a:schemeClr val="accent1">
+              <a:shade val="15000"/>
+            </a:schemeClr>
+          </a:lnRef>
+          <a:fillRef idx="1">
+            <a:schemeClr val="accent1"/>
+          </a:fillRef>
+          <a:effectRef idx="0">
+            <a:schemeClr val="accent1"/>
+          </a:effectRef>
+          <a:fontRef idx="minor">
+            <a:schemeClr val="lt1"/>
+          </a:fontRef>
+        </p:style>
+        <p:txBody>
+          <a:bodyPr rtlCol="0" anchor="ctr"/>
+          <a:lstStyle/>
+          <a:p>
+            <a:pPr algn="ctr"/>
+            <a:endParaRPr lang="en-GB"/>
+          </a:p>
+        </p:txBody>
+      </p:sp>
+      <p:sp>
+        <p:nvSpPr>
+          <p:cNvPr id="3" name="Arrow: Right 2">
+            <a:extLst>
+              <a:ext uri="{FF2B5EF4-FFF2-40B4-BE49-F238E27FC236}">
+                <a16:creationId xmlns:a16="http://schemas.microsoft.com/office/drawing/2014/main" id="{39FA391B-1469-6F06-FC2D-E61E3FBD1D82}"/>
+              </a:ext>
+            </a:extLst>
+          </p:cNvPr>
+          <p:cNvSpPr/>
+          <p:nvPr/>
+        </p:nvSpPr>
+        <p:spPr>
+          <a:xfrm>
+            <a:off x="1531290" y="1603874"/>
+            <a:ext cx="2609290" cy="353083"/>
+          </a:xfrm>
+          <a:prstGeom prst="rightArrow">
+            <a:avLst/>
+          </a:prstGeom>
+          <a:solidFill>
+            <a:srgbClr val="00B1C1"/>
+          </a:solidFill>
+          <a:ln>
+            <a:solidFill>
+              <a:schemeClr val="accent2"/>
+            </a:solidFill>
+          </a:ln>
+        </p:spPr>
+        <p:style>
+          <a:lnRef idx="2">
+            <a:schemeClr val="accent1">
+              <a:shade val="15000"/>
+            </a:schemeClr>
+          </a:lnRef>
+          <a:fillRef idx="1">
+            <a:schemeClr val="accent1"/>
+          </a:fillRef>
+          <a:effectRef idx="0">
+            <a:schemeClr val="accent1"/>
+          </a:effectRef>
+          <a:fontRef idx="minor">
+            <a:schemeClr val="lt1"/>
+          </a:fontRef>
+        </p:style>
+        <p:txBody>
+          <a:bodyPr rtlCol="0" anchor="ctr"/>
+          <a:lstStyle/>
+          <a:p>
+            <a:pPr algn="ctr"/>
+            <a:endParaRPr lang="en-GB"/>
+          </a:p>
+        </p:txBody>
+      </p:sp>
+      <p:pic>
+        <p:nvPicPr>
+          <p:cNvPr id="4" name="Graphic 3" descr="Gavel with solid fill">
+            <a:extLst>
+              <a:ext uri="{FF2B5EF4-FFF2-40B4-BE49-F238E27FC236}">
+                <a16:creationId xmlns:a16="http://schemas.microsoft.com/office/drawing/2014/main" id="{44FF1124-9FE8-D841-CE7C-1608ABECE5B2}"/>
+              </a:ext>
+            </a:extLst>
+          </p:cNvPr>
+          <p:cNvPicPr>
+            <a:picLocks noChangeAspect="1"/>
+          </p:cNvPicPr>
+          <p:nvPr/>
+        </p:nvPicPr>
+        <p:blipFill>
+          <a:blip>
+            <a:extLst>
+              <a:ext uri="{96DAC541-7B7A-43D3-8B79-37D633B846F1}">
+                <asvg:svgBlip xmlns:asvg="http://schemas.microsoft.com/office/drawing/2016/SVG/main" r:embed="rId2"/>
+              </a:ext>
+            </a:extLst>
+          </a:blip>
+          <a:srcRect/>
+          <a:stretch/>
+        </p:blipFill>
+        <p:spPr>
+          <a:xfrm>
+            <a:off x="4134334" y="1396350"/>
+            <a:ext cx="761707" cy="761707"/>
+          </a:xfrm>
+          <a:prstGeom prst="rect">
+            <a:avLst/>
+          </a:prstGeom>
+        </p:spPr>
+      </p:pic>
+      <p:sp>
+        <p:nvSpPr>
+          <p:cNvPr id="5" name="Arrow: Right 4">
+            <a:extLst>
+              <a:ext uri="{FF2B5EF4-FFF2-40B4-BE49-F238E27FC236}">
+                <a16:creationId xmlns:a16="http://schemas.microsoft.com/office/drawing/2014/main" id="{AE4E1E01-B8B1-EF4C-0B98-A869C85C5CFC}"/>
+              </a:ext>
+            </a:extLst>
+          </p:cNvPr>
+          <p:cNvSpPr/>
+          <p:nvPr/>
+        </p:nvSpPr>
+        <p:spPr>
+          <a:xfrm>
+            <a:off x="1531290" y="2192517"/>
+            <a:ext cx="1769518" cy="353083"/>
+          </a:xfrm>
+          <a:prstGeom prst="rightArrow">
+            <a:avLst/>
+          </a:prstGeom>
+          <a:solidFill>
+            <a:srgbClr val="00B1C1"/>
+          </a:solidFill>
+          <a:ln>
+            <a:solidFill>
+              <a:schemeClr val="accent5"/>
+            </a:solidFill>
+          </a:ln>
+        </p:spPr>
+        <p:style>
+          <a:lnRef idx="2">
+            <a:schemeClr val="accent1">
+              <a:shade val="15000"/>
+            </a:schemeClr>
+          </a:lnRef>
+          <a:fillRef idx="1">
+            <a:schemeClr val="accent1"/>
+          </a:fillRef>
+          <a:effectRef idx="0">
+            <a:schemeClr val="accent1"/>
+          </a:effectRef>
+          <a:fontRef idx="minor">
+            <a:schemeClr val="lt1"/>
+          </a:fontRef>
+        </p:style>
+        <p:txBody>
+          <a:bodyPr rtlCol="0" anchor="ctr"/>
+          <a:lstStyle/>
+          <a:p>
+            <a:pPr algn="ctr"/>
+            <a:endParaRPr lang="en-GB"/>
+          </a:p>
+        </p:txBody>
+      </p:sp>
+      <p:sp>
+        <p:nvSpPr>
+          <p:cNvPr id="6" name="Rectangle 5">
+            <a:extLst>
+              <a:ext uri="{FF2B5EF4-FFF2-40B4-BE49-F238E27FC236}">
+                <a16:creationId xmlns:a16="http://schemas.microsoft.com/office/drawing/2014/main" id="{72F4BD24-818F-F7FC-2BDA-3A0F7294C54F}"/>
+              </a:ext>
+            </a:extLst>
+          </p:cNvPr>
+          <p:cNvSpPr/>
+          <p:nvPr/>
+        </p:nvSpPr>
+        <p:spPr>
+          <a:xfrm>
+            <a:off x="1525044" y="2929199"/>
+            <a:ext cx="3509045" cy="190375"/>
+          </a:xfrm>
+          <a:prstGeom prst="rect">
+            <a:avLst/>
+          </a:prstGeom>
+          <a:solidFill>
+            <a:srgbClr val="00B1C1"/>
+          </a:solidFill>
+          <a:ln>
+            <a:solidFill>
+              <a:schemeClr val="accent4"/>
+            </a:solidFill>
+          </a:ln>
+        </p:spPr>
+        <p:style>
+          <a:lnRef idx="2">
+            <a:schemeClr val="accent1">
+              <a:shade val="15000"/>
+            </a:schemeClr>
+          </a:lnRef>
+          <a:fillRef idx="1">
+            <a:schemeClr val="accent1"/>
+          </a:fillRef>
+          <a:effectRef idx="0">
+            <a:schemeClr val="accent1"/>
+          </a:effectRef>
+          <a:fontRef idx="minor">
+            <a:schemeClr val="lt1"/>
+          </a:fontRef>
+        </p:style>
+        <p:txBody>
+          <a:bodyPr rtlCol="0" anchor="ctr"/>
+          <a:lstStyle/>
+          <a:p>
+            <a:pPr algn="ctr"/>
+            <a:endParaRPr lang="en-GB"/>
+          </a:p>
+        </p:txBody>
+      </p:sp>
+      <p:pic>
+        <p:nvPicPr>
+          <p:cNvPr id="7" name="Graphic 6" descr="Gavel with solid fill">
+            <a:extLst>
+              <a:ext uri="{FF2B5EF4-FFF2-40B4-BE49-F238E27FC236}">
+                <a16:creationId xmlns:a16="http://schemas.microsoft.com/office/drawing/2014/main" id="{44E0DBE2-0EAB-04AD-0E68-AB917B49ECCF}"/>
+              </a:ext>
+            </a:extLst>
+          </p:cNvPr>
+          <p:cNvPicPr>
+            <a:picLocks noChangeAspect="1"/>
+          </p:cNvPicPr>
+          <p:nvPr/>
+        </p:nvPicPr>
+        <p:blipFill>
+          <a:blip>
+            <a:extLst>
+              <a:ext uri="{96DAC541-7B7A-43D3-8B79-37D633B846F1}">
+                <asvg:svgBlip xmlns:asvg="http://schemas.microsoft.com/office/drawing/2016/SVG/main" r:embed="rId3"/>
+              </a:ext>
+            </a:extLst>
+          </a:blip>
+          <a:srcRect/>
+          <a:stretch/>
+        </p:blipFill>
+        <p:spPr>
+          <a:xfrm>
+            <a:off x="3282393" y="1988204"/>
+            <a:ext cx="761707" cy="761707"/>
+          </a:xfrm>
+          <a:prstGeom prst="rect">
+            <a:avLst/>
+          </a:prstGeom>
+        </p:spPr>
+      </p:pic>
+      <p:pic>
+        <p:nvPicPr>
+          <p:cNvPr id="8" name="Graphic 7" descr="Badge Question Mark with solid fill">
+            <a:extLst>
+              <a:ext uri="{FF2B5EF4-FFF2-40B4-BE49-F238E27FC236}">
+                <a16:creationId xmlns:a16="http://schemas.microsoft.com/office/drawing/2014/main" id="{BEB83B8A-8C34-791C-4EC2-B585FF02C9EC}"/>
+              </a:ext>
+            </a:extLst>
+          </p:cNvPr>
+          <p:cNvPicPr>
+            <a:picLocks noChangeAspect="1"/>
+          </p:cNvPicPr>
+          <p:nvPr/>
+        </p:nvPicPr>
+        <p:blipFill>
+          <a:blip>
+            <a:extLst>
+              <a:ext uri="{96DAC541-7B7A-43D3-8B79-37D633B846F1}">
+                <asvg:svgBlip xmlns:asvg="http://schemas.microsoft.com/office/drawing/2016/SVG/main" r:embed="rId4"/>
+              </a:ext>
+            </a:extLst>
+          </a:blip>
+          <a:srcRect/>
+          <a:stretch/>
+        </p:blipFill>
+        <p:spPr>
+          <a:xfrm>
+            <a:off x="4755206" y="2681420"/>
+            <a:ext cx="648000" cy="648000"/>
+          </a:xfrm>
+          <a:prstGeom prst="rect">
+            <a:avLst/>
+          </a:prstGeom>
+        </p:spPr>
+      </p:pic>
+      <p:sp>
+        <p:nvSpPr>
+          <p:cNvPr id="9" name="TextBox 8">
+            <a:extLst>
+              <a:ext uri="{FF2B5EF4-FFF2-40B4-BE49-F238E27FC236}">
+                <a16:creationId xmlns:a16="http://schemas.microsoft.com/office/drawing/2014/main" id="{0EA43953-5EDB-B1D8-64EE-D1D44480C47B}"/>
+              </a:ext>
+            </a:extLst>
+          </p:cNvPr>
+          <p:cNvSpPr txBox="1"/>
+          <p:nvPr/>
+        </p:nvSpPr>
+        <p:spPr>
+          <a:xfrm>
+            <a:off x="1168851" y="929432"/>
+            <a:ext cx="724878" cy="400110"/>
+          </a:xfrm>
+          <a:prstGeom prst="rect">
+            <a:avLst/>
+          </a:prstGeom>
+          <a:noFill/>
+        </p:spPr>
+        <p:txBody>
+          <a:bodyPr wrap="none" rtlCol="0">
+            <a:spAutoFit/>
+          </a:bodyPr>
+          <a:lstStyle/>
+          <a:p>
+            <a:r>
+              <a:rPr lang="en-GB" sz="2000" dirty="0"/>
+              <a:t>Start</a:t>
+            </a:r>
+          </a:p>
+        </p:txBody>
+      </p:sp>
+      <p:sp>
+        <p:nvSpPr>
+          <p:cNvPr id="10" name="Arrow: Right 9">
+            <a:extLst>
+              <a:ext uri="{FF2B5EF4-FFF2-40B4-BE49-F238E27FC236}">
+                <a16:creationId xmlns:a16="http://schemas.microsoft.com/office/drawing/2014/main" id="{CF451E8A-CF63-F9A5-1BED-3931649E2FBA}"/>
+              </a:ext>
+            </a:extLst>
+          </p:cNvPr>
+          <p:cNvSpPr/>
+          <p:nvPr/>
+        </p:nvSpPr>
+        <p:spPr>
+          <a:xfrm>
+            <a:off x="1525044" y="3442745"/>
+            <a:ext cx="2609290" cy="353083"/>
+          </a:xfrm>
+          <a:prstGeom prst="rightArrow">
+            <a:avLst/>
+          </a:prstGeom>
+          <a:solidFill>
+            <a:srgbClr val="00B1C1"/>
+          </a:solidFill>
+          <a:ln>
+            <a:solidFill>
+              <a:schemeClr val="accent1"/>
+            </a:solidFill>
+          </a:ln>
+        </p:spPr>
+        <p:style>
+          <a:lnRef idx="2">
+            <a:schemeClr val="accent1">
+              <a:shade val="15000"/>
+            </a:schemeClr>
+          </a:lnRef>
+          <a:fillRef idx="1">
+            <a:schemeClr val="accent1"/>
+          </a:fillRef>
+          <a:effectRef idx="0">
+            <a:schemeClr val="accent1"/>
+          </a:effectRef>
+          <a:fontRef idx="minor">
+            <a:schemeClr val="lt1"/>
+          </a:fontRef>
+        </p:style>
+        <p:txBody>
+          <a:bodyPr rtlCol="0" anchor="ctr"/>
+          <a:lstStyle/>
+          <a:p>
+            <a:pPr algn="ctr"/>
+            <a:endParaRPr lang="en-GB"/>
+          </a:p>
+        </p:txBody>
+      </p:sp>
+      <p:pic>
+        <p:nvPicPr>
+          <p:cNvPr id="11" name="Graphic 10" descr="Gavel with solid fill">
+            <a:extLst>
+              <a:ext uri="{FF2B5EF4-FFF2-40B4-BE49-F238E27FC236}">
+                <a16:creationId xmlns:a16="http://schemas.microsoft.com/office/drawing/2014/main" id="{7665FDFF-1451-CDEC-8A61-E328F713EE2A}"/>
+              </a:ext>
+            </a:extLst>
+          </p:cNvPr>
+          <p:cNvPicPr>
+            <a:picLocks noChangeAspect="1"/>
+          </p:cNvPicPr>
+          <p:nvPr/>
+        </p:nvPicPr>
+        <p:blipFill>
+          <a:blip>
+            <a:extLst>
+              <a:ext uri="{96DAC541-7B7A-43D3-8B79-37D633B846F1}">
+                <asvg:svgBlip xmlns:asvg="http://schemas.microsoft.com/office/drawing/2016/SVG/main" r:embed="rId5"/>
+              </a:ext>
+            </a:extLst>
+          </a:blip>
+          <a:srcRect/>
+          <a:stretch/>
+        </p:blipFill>
+        <p:spPr>
+          <a:xfrm>
+            <a:off x="4110148" y="3216394"/>
+            <a:ext cx="761707" cy="761707"/>
+          </a:xfrm>
+          <a:prstGeom prst="rect">
+            <a:avLst/>
+          </a:prstGeom>
+        </p:spPr>
+      </p:pic>
+      <p:cxnSp>
+        <p:nvCxnSpPr>
+          <p:cNvPr id="12" name="Straight Connector 11">
+            <a:extLst>
+              <a:ext uri="{FF2B5EF4-FFF2-40B4-BE49-F238E27FC236}">
+                <a16:creationId xmlns:a16="http://schemas.microsoft.com/office/drawing/2014/main" id="{F58DB2C4-6618-9DD2-C862-7B0043AACA08}"/>
+              </a:ext>
+            </a:extLst>
+          </p:cNvPr>
+          <p:cNvCxnSpPr>
+            <a:cxnSpLocks/>
+          </p:cNvCxnSpPr>
+          <p:nvPr/>
+        </p:nvCxnSpPr>
+        <p:spPr>
+          <a:xfrm>
+            <a:off x="1531290" y="1425581"/>
+            <a:ext cx="0" cy="3170067"/>
+          </a:xfrm>
+          <a:prstGeom prst="line">
+            <a:avLst/>
+          </a:prstGeom>
+          <a:ln w="38100">
+            <a:solidFill>
+              <a:schemeClr val="tx1"/>
+            </a:solidFill>
+            <a:prstDash val="solid"/>
+          </a:ln>
+        </p:spPr>
+        <p:style>
+          <a:lnRef idx="1">
+            <a:schemeClr val="accent1"/>
+          </a:lnRef>
+          <a:fillRef idx="0">
+            <a:schemeClr val="accent1"/>
+          </a:fillRef>
+          <a:effectRef idx="0">
+            <a:schemeClr val="accent1"/>
+          </a:effectRef>
+          <a:fontRef idx="minor">
+            <a:schemeClr val="tx1"/>
+          </a:fontRef>
+        </p:style>
+      </p:cxnSp>
+      <p:pic>
+        <p:nvPicPr>
+          <p:cNvPr id="13" name="Graphic 12" descr="House with solid fill">
+            <a:extLst>
+              <a:ext uri="{FF2B5EF4-FFF2-40B4-BE49-F238E27FC236}">
+                <a16:creationId xmlns:a16="http://schemas.microsoft.com/office/drawing/2014/main" id="{3A7D97AA-6AA9-3589-C799-9A6561DA6817}"/>
+              </a:ext>
+            </a:extLst>
+          </p:cNvPr>
+          <p:cNvPicPr>
+            <a:picLocks noChangeAspect="1"/>
+          </p:cNvPicPr>
+          <p:nvPr/>
+        </p:nvPicPr>
+        <p:blipFill>
+          <a:blip>
+            <a:extLst>
+              <a:ext uri="{96DAC541-7B7A-43D3-8B79-37D633B846F1}">
+                <asvg:svgBlip xmlns:asvg="http://schemas.microsoft.com/office/drawing/2016/SVG/main" r:embed="rId6"/>
+              </a:ext>
+            </a:extLst>
+          </a:blip>
+          <a:srcRect/>
+          <a:stretch/>
+        </p:blipFill>
+        <p:spPr>
+          <a:xfrm>
+            <a:off x="698423" y="1396350"/>
+            <a:ext cx="684000" cy="684000"/>
+          </a:xfrm>
+          <a:prstGeom prst="rect">
+            <a:avLst/>
+          </a:prstGeom>
+        </p:spPr>
+      </p:pic>
+      <p:pic>
+        <p:nvPicPr>
+          <p:cNvPr id="15" name="Graphic 14" descr="House with solid fill">
+            <a:extLst>
+              <a:ext uri="{FF2B5EF4-FFF2-40B4-BE49-F238E27FC236}">
+                <a16:creationId xmlns:a16="http://schemas.microsoft.com/office/drawing/2014/main" id="{CF342379-284D-B46E-21BF-E9604A4DA863}"/>
+              </a:ext>
+            </a:extLst>
+          </p:cNvPr>
+          <p:cNvPicPr>
+            <a:picLocks noChangeAspect="1"/>
+          </p:cNvPicPr>
+          <p:nvPr/>
+        </p:nvPicPr>
+        <p:blipFill>
+          <a:blip>
+            <a:extLst>
+              <a:ext uri="{96DAC541-7B7A-43D3-8B79-37D633B846F1}">
+                <asvg:svgBlip xmlns:asvg="http://schemas.microsoft.com/office/drawing/2016/SVG/main" r:embed="rId7"/>
+              </a:ext>
+            </a:extLst>
+          </a:blip>
+          <a:srcRect/>
+          <a:stretch/>
+        </p:blipFill>
+        <p:spPr>
+          <a:xfrm>
+            <a:off x="694593" y="2629367"/>
+            <a:ext cx="684000" cy="684000"/>
+          </a:xfrm>
+          <a:prstGeom prst="rect">
+            <a:avLst/>
+          </a:prstGeom>
+        </p:spPr>
+      </p:pic>
+      <p:pic>
+        <p:nvPicPr>
+          <p:cNvPr id="27" name="Graphic 26" descr="House with solid fill">
+            <a:extLst>
+              <a:ext uri="{FF2B5EF4-FFF2-40B4-BE49-F238E27FC236}">
+                <a16:creationId xmlns:a16="http://schemas.microsoft.com/office/drawing/2014/main" id="{CC7EC3DC-06AB-37E0-0811-16FCB048480C}"/>
+              </a:ext>
+            </a:extLst>
+          </p:cNvPr>
+          <p:cNvPicPr>
+            <a:picLocks noChangeAspect="1"/>
+          </p:cNvPicPr>
+          <p:nvPr/>
+        </p:nvPicPr>
+        <p:blipFill>
+          <a:blip>
+            <a:extLst>
+              <a:ext uri="{96DAC541-7B7A-43D3-8B79-37D633B846F1}">
+                <asvg:svgBlip xmlns:asvg="http://schemas.microsoft.com/office/drawing/2016/SVG/main" r:embed="rId8"/>
+              </a:ext>
+            </a:extLst>
+          </a:blip>
+          <a:srcRect/>
+          <a:stretch/>
+        </p:blipFill>
+        <p:spPr>
+          <a:xfrm>
+            <a:off x="690763" y="2021818"/>
+            <a:ext cx="684000" cy="684000"/>
+          </a:xfrm>
+          <a:prstGeom prst="rect">
+            <a:avLst/>
+          </a:prstGeom>
+        </p:spPr>
+      </p:pic>
+      <p:pic>
+        <p:nvPicPr>
+          <p:cNvPr id="29" name="Graphic 28" descr="House with solid fill">
+            <a:extLst>
+              <a:ext uri="{FF2B5EF4-FFF2-40B4-BE49-F238E27FC236}">
+                <a16:creationId xmlns:a16="http://schemas.microsoft.com/office/drawing/2014/main" id="{C683A135-3FB3-31BC-EA26-E1A105899F0E}"/>
+              </a:ext>
+            </a:extLst>
+          </p:cNvPr>
+          <p:cNvPicPr>
+            <a:picLocks noChangeAspect="1"/>
+          </p:cNvPicPr>
+          <p:nvPr/>
+        </p:nvPicPr>
+        <p:blipFill>
+          <a:blip>
+            <a:extLst>
+              <a:ext uri="{96DAC541-7B7A-43D3-8B79-37D633B846F1}">
+                <asvg:svgBlip xmlns:asvg="http://schemas.microsoft.com/office/drawing/2016/SVG/main" r:embed="rId9"/>
+              </a:ext>
+            </a:extLst>
+          </a:blip>
+          <a:srcRect/>
+          <a:stretch/>
+        </p:blipFill>
+        <p:spPr>
+          <a:xfrm>
+            <a:off x="698423" y="3228586"/>
+            <a:ext cx="684000" cy="684000"/>
+          </a:xfrm>
+          <a:prstGeom prst="rect">
+            <a:avLst/>
+          </a:prstGeom>
+        </p:spPr>
+      </p:pic>
+      <p:pic>
+        <p:nvPicPr>
+          <p:cNvPr id="36" name="Graphic 35" descr="Badge Question Mark with solid fill">
+            <a:extLst>
+              <a:ext uri="{FF2B5EF4-FFF2-40B4-BE49-F238E27FC236}">
+                <a16:creationId xmlns:a16="http://schemas.microsoft.com/office/drawing/2014/main" id="{DA85E563-DB20-5AC2-27BB-50DE856AD9FF}"/>
+              </a:ext>
+            </a:extLst>
+          </p:cNvPr>
+          <p:cNvPicPr>
+            <a:picLocks noChangeAspect="1"/>
+          </p:cNvPicPr>
+          <p:nvPr/>
+        </p:nvPicPr>
+        <p:blipFill>
+          <a:blip>
+            <a:extLst>
+              <a:ext uri="{96DAC541-7B7A-43D3-8B79-37D633B846F1}">
+                <asvg:svgBlip xmlns:asvg="http://schemas.microsoft.com/office/drawing/2016/SVG/main" r:embed="rId10"/>
+              </a:ext>
+            </a:extLst>
+          </a:blip>
+          <a:srcRect/>
+          <a:stretch/>
+        </p:blipFill>
+        <p:spPr>
+          <a:xfrm>
+            <a:off x="4864200" y="3875375"/>
+            <a:ext cx="648000" cy="648000"/>
+          </a:xfrm>
+          <a:prstGeom prst="rect">
+            <a:avLst/>
+          </a:prstGeom>
+        </p:spPr>
+      </p:pic>
+      <p:pic>
+        <p:nvPicPr>
+          <p:cNvPr id="40" name="Graphic 39" descr="House with solid fill">
+            <a:extLst>
+              <a:ext uri="{FF2B5EF4-FFF2-40B4-BE49-F238E27FC236}">
+                <a16:creationId xmlns:a16="http://schemas.microsoft.com/office/drawing/2014/main" id="{B98D88DE-C431-EE3C-3D74-3F2B31671381}"/>
+              </a:ext>
+            </a:extLst>
+          </p:cNvPr>
+          <p:cNvPicPr>
+            <a:picLocks noChangeAspect="1"/>
+          </p:cNvPicPr>
+          <p:nvPr/>
+        </p:nvPicPr>
+        <p:blipFill>
+          <a:blip>
+            <a:extLst>
+              <a:ext uri="{96DAC541-7B7A-43D3-8B79-37D633B846F1}">
+                <asvg:svgBlip xmlns:asvg="http://schemas.microsoft.com/office/drawing/2016/SVG/main" r:embed="rId11"/>
+              </a:ext>
+            </a:extLst>
+          </a:blip>
+          <a:srcRect/>
+          <a:stretch/>
+        </p:blipFill>
+        <p:spPr>
+          <a:xfrm>
+            <a:off x="698423" y="3821267"/>
+            <a:ext cx="684000" cy="684000"/>
+          </a:xfrm>
+          <a:prstGeom prst="rect">
+            <a:avLst/>
+          </a:prstGeom>
+        </p:spPr>
+      </p:pic>
+      <p:sp>
+        <p:nvSpPr>
+          <p:cNvPr id="62" name="TextBox 61">
+            <a:extLst>
+              <a:ext uri="{FF2B5EF4-FFF2-40B4-BE49-F238E27FC236}">
+                <a16:creationId xmlns:a16="http://schemas.microsoft.com/office/drawing/2014/main" id="{4B2B33C8-54F0-0CE4-E7FE-7CE6B107E132}"/>
+              </a:ext>
+            </a:extLst>
+          </p:cNvPr>
+          <p:cNvSpPr txBox="1"/>
+          <p:nvPr/>
+        </p:nvSpPr>
+        <p:spPr>
+          <a:xfrm>
+            <a:off x="1168851" y="4728358"/>
+            <a:ext cx="2888521" cy="369332"/>
+          </a:xfrm>
+          <a:prstGeom prst="rect">
+            <a:avLst/>
+          </a:prstGeom>
+          <a:noFill/>
+        </p:spPr>
+        <p:txBody>
+          <a:bodyPr wrap="square" rtlCol="0">
+            <a:spAutoFit/>
+          </a:bodyPr>
+          <a:lstStyle/>
+          <a:p>
+            <a:r>
+              <a:rPr lang="en-GB" b="1" dirty="0"/>
+              <a:t>Event: </a:t>
+            </a:r>
+            <a:r>
+              <a:rPr lang="en-GB" dirty="0"/>
+              <a:t>house sale</a:t>
+            </a:r>
+          </a:p>
+        </p:txBody>
+      </p:sp>
+      <p:sp>
+        <p:nvSpPr>
+          <p:cNvPr id="63" name="Rectangle 62">
+            <a:extLst>
+              <a:ext uri="{FF2B5EF4-FFF2-40B4-BE49-F238E27FC236}">
+                <a16:creationId xmlns:a16="http://schemas.microsoft.com/office/drawing/2014/main" id="{5D4FBD48-49D3-6377-24B7-E65F67AFD937}"/>
+              </a:ext>
+            </a:extLst>
+          </p:cNvPr>
+          <p:cNvSpPr/>
+          <p:nvPr/>
+        </p:nvSpPr>
+        <p:spPr>
+          <a:xfrm>
+            <a:off x="6736545" y="3516401"/>
+            <a:ext cx="3509045" cy="190375"/>
+          </a:xfrm>
+          <a:prstGeom prst="rect">
+            <a:avLst/>
+          </a:prstGeom>
+          <a:solidFill>
+            <a:srgbClr val="00B1C1"/>
+          </a:solidFill>
+          <a:ln>
+            <a:solidFill>
+              <a:schemeClr val="accent1"/>
+            </a:solidFill>
+          </a:ln>
+        </p:spPr>
+        <p:style>
+          <a:lnRef idx="2">
+            <a:schemeClr val="accent1">
+              <a:shade val="15000"/>
+            </a:schemeClr>
+          </a:lnRef>
+          <a:fillRef idx="1">
+            <a:schemeClr val="accent1"/>
+          </a:fillRef>
+          <a:effectRef idx="0">
+            <a:schemeClr val="accent1"/>
+          </a:effectRef>
+          <a:fontRef idx="minor">
+            <a:schemeClr val="lt1"/>
+          </a:fontRef>
+        </p:style>
+        <p:txBody>
+          <a:bodyPr rtlCol="0" anchor="ctr"/>
+          <a:lstStyle/>
+          <a:p>
+            <a:pPr algn="ctr"/>
+            <a:endParaRPr lang="en-GB"/>
+          </a:p>
+        </p:txBody>
+      </p:sp>
+      <p:sp>
+        <p:nvSpPr>
+          <p:cNvPr id="64" name="Arrow: Right 63">
+            <a:extLst>
+              <a:ext uri="{FF2B5EF4-FFF2-40B4-BE49-F238E27FC236}">
+                <a16:creationId xmlns:a16="http://schemas.microsoft.com/office/drawing/2014/main" id="{32B6A0AD-935B-1F93-3E35-BE388C2CC114}"/>
+              </a:ext>
+            </a:extLst>
+          </p:cNvPr>
+          <p:cNvSpPr/>
+          <p:nvPr/>
+        </p:nvSpPr>
+        <p:spPr>
+          <a:xfrm>
+            <a:off x="6728885" y="1564992"/>
+            <a:ext cx="2609290" cy="353083"/>
+          </a:xfrm>
+          <a:prstGeom prst="rightArrow">
+            <a:avLst/>
+          </a:prstGeom>
+          <a:solidFill>
+            <a:srgbClr val="00B1C1"/>
+          </a:solidFill>
+          <a:ln>
+            <a:solidFill>
+              <a:schemeClr val="accent2"/>
+            </a:solidFill>
+          </a:ln>
+        </p:spPr>
+        <p:style>
+          <a:lnRef idx="2">
+            <a:schemeClr val="accent1">
+              <a:shade val="15000"/>
+            </a:schemeClr>
+          </a:lnRef>
+          <a:fillRef idx="1">
+            <a:schemeClr val="accent1"/>
+          </a:fillRef>
+          <a:effectRef idx="0">
+            <a:schemeClr val="accent1"/>
+          </a:effectRef>
+          <a:fontRef idx="minor">
+            <a:schemeClr val="lt1"/>
+          </a:fontRef>
+        </p:style>
+        <p:txBody>
+          <a:bodyPr rtlCol="0" anchor="ctr"/>
+          <a:lstStyle/>
+          <a:p>
+            <a:pPr algn="ctr"/>
+            <a:endParaRPr lang="en-GB"/>
+          </a:p>
+        </p:txBody>
+      </p:sp>
+      <p:pic>
+        <p:nvPicPr>
+          <p:cNvPr id="65" name="Graphic 64" descr="Flower without stem with solid fill">
+            <a:extLst>
+              <a:ext uri="{FF2B5EF4-FFF2-40B4-BE49-F238E27FC236}">
+                <a16:creationId xmlns:a16="http://schemas.microsoft.com/office/drawing/2014/main" id="{0D5EDE66-4FE5-EA9A-F760-8B7E61567570}"/>
+              </a:ext>
+            </a:extLst>
+          </p:cNvPr>
+          <p:cNvPicPr>
+            <a:picLocks noChangeAspect="1"/>
+          </p:cNvPicPr>
+          <p:nvPr/>
+        </p:nvPicPr>
+        <p:blipFill>
+          <a:blip>
+            <a:extLst>
+              <a:ext uri="{96DAC541-7B7A-43D3-8B79-37D633B846F1}">
+                <asvg:svgBlip xmlns:asvg="http://schemas.microsoft.com/office/drawing/2016/SVG/main" r:embed="rId12"/>
+              </a:ext>
+            </a:extLst>
+          </a:blip>
+          <a:srcRect/>
+          <a:stretch/>
+        </p:blipFill>
+        <p:spPr>
+          <a:xfrm>
+            <a:off x="9331929" y="1357468"/>
+            <a:ext cx="761707" cy="761707"/>
+          </a:xfrm>
+          <a:prstGeom prst="rect">
+            <a:avLst/>
+          </a:prstGeom>
+        </p:spPr>
+      </p:pic>
+      <p:sp>
+        <p:nvSpPr>
+          <p:cNvPr id="66" name="Arrow: Right 65">
+            <a:extLst>
+              <a:ext uri="{FF2B5EF4-FFF2-40B4-BE49-F238E27FC236}">
+                <a16:creationId xmlns:a16="http://schemas.microsoft.com/office/drawing/2014/main" id="{D49D7FBB-2925-4BA9-E668-6D37C4BAF99A}"/>
+              </a:ext>
+            </a:extLst>
+          </p:cNvPr>
+          <p:cNvSpPr/>
+          <p:nvPr/>
+        </p:nvSpPr>
+        <p:spPr>
+          <a:xfrm>
+            <a:off x="6720891" y="2795167"/>
+            <a:ext cx="1942258" cy="353083"/>
+          </a:xfrm>
+          <a:prstGeom prst="rightArrow">
+            <a:avLst/>
+          </a:prstGeom>
+          <a:solidFill>
+            <a:srgbClr val="00B1C1"/>
+          </a:solidFill>
+          <a:ln>
+            <a:solidFill>
+              <a:schemeClr val="accent4"/>
+            </a:solidFill>
+          </a:ln>
+        </p:spPr>
+        <p:style>
+          <a:lnRef idx="2">
+            <a:schemeClr val="accent1">
+              <a:shade val="15000"/>
+            </a:schemeClr>
+          </a:lnRef>
+          <a:fillRef idx="1">
+            <a:schemeClr val="accent1"/>
+          </a:fillRef>
+          <a:effectRef idx="0">
+            <a:schemeClr val="accent1"/>
+          </a:effectRef>
+          <a:fontRef idx="minor">
+            <a:schemeClr val="lt1"/>
+          </a:fontRef>
+        </p:style>
+        <p:txBody>
+          <a:bodyPr rtlCol="0" anchor="ctr"/>
+          <a:lstStyle/>
+          <a:p>
+            <a:pPr algn="ctr"/>
+            <a:endParaRPr lang="en-GB"/>
+          </a:p>
+        </p:txBody>
+      </p:sp>
+      <p:sp>
+        <p:nvSpPr>
+          <p:cNvPr id="70" name="TextBox 69">
+            <a:extLst>
+              <a:ext uri="{FF2B5EF4-FFF2-40B4-BE49-F238E27FC236}">
+                <a16:creationId xmlns:a16="http://schemas.microsoft.com/office/drawing/2014/main" id="{57FCCCD9-8E42-54C1-ACDA-035057A5F1F3}"/>
+              </a:ext>
+            </a:extLst>
+          </p:cNvPr>
+          <p:cNvSpPr txBox="1"/>
+          <p:nvPr/>
+        </p:nvSpPr>
+        <p:spPr>
+          <a:xfrm>
+            <a:off x="6366446" y="890550"/>
+            <a:ext cx="724878" cy="400110"/>
+          </a:xfrm>
+          <a:prstGeom prst="rect">
+            <a:avLst/>
+          </a:prstGeom>
+          <a:noFill/>
+        </p:spPr>
+        <p:txBody>
+          <a:bodyPr wrap="none" rtlCol="0">
+            <a:spAutoFit/>
+          </a:bodyPr>
+          <a:lstStyle/>
+          <a:p>
+            <a:r>
+              <a:rPr lang="en-GB" sz="2000" dirty="0"/>
+              <a:t>Start</a:t>
+            </a:r>
+          </a:p>
+        </p:txBody>
+      </p:sp>
+      <p:sp>
+        <p:nvSpPr>
+          <p:cNvPr id="71" name="Arrow: Right 70">
+            <a:extLst>
+              <a:ext uri="{FF2B5EF4-FFF2-40B4-BE49-F238E27FC236}">
+                <a16:creationId xmlns:a16="http://schemas.microsoft.com/office/drawing/2014/main" id="{392703D7-59BF-12D6-338C-DD53D2547EA0}"/>
+              </a:ext>
+            </a:extLst>
+          </p:cNvPr>
+          <p:cNvSpPr/>
+          <p:nvPr/>
+        </p:nvSpPr>
+        <p:spPr>
+          <a:xfrm>
+            <a:off x="6722639" y="4007491"/>
+            <a:ext cx="2609290" cy="353083"/>
+          </a:xfrm>
+          <a:prstGeom prst="rightArrow">
+            <a:avLst/>
+          </a:prstGeom>
+          <a:solidFill>
+            <a:srgbClr val="00B1C1"/>
+          </a:solidFill>
+          <a:ln>
+            <a:solidFill>
+              <a:schemeClr val="accent3"/>
+            </a:solidFill>
+          </a:ln>
+        </p:spPr>
+        <p:style>
+          <a:lnRef idx="2">
+            <a:schemeClr val="accent1">
+              <a:shade val="15000"/>
+            </a:schemeClr>
+          </a:lnRef>
+          <a:fillRef idx="1">
+            <a:schemeClr val="accent1"/>
+          </a:fillRef>
+          <a:effectRef idx="0">
+            <a:schemeClr val="accent1"/>
+          </a:effectRef>
+          <a:fontRef idx="minor">
+            <a:schemeClr val="lt1"/>
+          </a:fontRef>
+        </p:style>
+        <p:txBody>
+          <a:bodyPr rtlCol="0" anchor="ctr"/>
+          <a:lstStyle/>
+          <a:p>
+            <a:pPr algn="ctr"/>
+            <a:endParaRPr lang="en-GB"/>
+          </a:p>
+        </p:txBody>
+      </p:sp>
+      <p:pic>
+        <p:nvPicPr>
+          <p:cNvPr id="72" name="Graphic 71" descr="Flower without stem with solid fill">
+            <a:extLst>
+              <a:ext uri="{FF2B5EF4-FFF2-40B4-BE49-F238E27FC236}">
+                <a16:creationId xmlns:a16="http://schemas.microsoft.com/office/drawing/2014/main" id="{FA1C47BD-2057-1DC4-CDB6-919CE96D9EBB}"/>
+              </a:ext>
+            </a:extLst>
+          </p:cNvPr>
+          <p:cNvPicPr>
+            <a:picLocks noChangeAspect="1"/>
+          </p:cNvPicPr>
+          <p:nvPr/>
+        </p:nvPicPr>
+        <p:blipFill>
+          <a:blip>
+            <a:extLst>
+              <a:ext uri="{96DAC541-7B7A-43D3-8B79-37D633B846F1}">
+                <asvg:svgBlip xmlns:asvg="http://schemas.microsoft.com/office/drawing/2016/SVG/main" r:embed="rId13"/>
+              </a:ext>
+            </a:extLst>
+          </a:blip>
+          <a:srcRect/>
+          <a:stretch/>
+        </p:blipFill>
+        <p:spPr>
+          <a:xfrm>
+            <a:off x="9307742" y="3779639"/>
+            <a:ext cx="761707" cy="761707"/>
+          </a:xfrm>
+          <a:prstGeom prst="rect">
+            <a:avLst/>
+          </a:prstGeom>
+        </p:spPr>
+      </p:pic>
+      <p:pic>
+        <p:nvPicPr>
+          <p:cNvPr id="74" name="Graphic 73" descr="Flowers in pot with solid fill">
+            <a:extLst>
+              <a:ext uri="{FF2B5EF4-FFF2-40B4-BE49-F238E27FC236}">
+                <a16:creationId xmlns:a16="http://schemas.microsoft.com/office/drawing/2014/main" id="{CD7049CC-B378-8E9B-092B-96945A8649DF}"/>
+              </a:ext>
+            </a:extLst>
+          </p:cNvPr>
+          <p:cNvPicPr>
+            <a:picLocks noChangeAspect="1"/>
+          </p:cNvPicPr>
+          <p:nvPr/>
+        </p:nvPicPr>
+        <p:blipFill>
+          <a:blip>
+            <a:extLst>
+              <a:ext uri="{96DAC541-7B7A-43D3-8B79-37D633B846F1}">
+                <asvg:svgBlip xmlns:asvg="http://schemas.microsoft.com/office/drawing/2016/SVG/main" r:embed="rId14"/>
+              </a:ext>
+            </a:extLst>
+          </a:blip>
+          <a:srcRect/>
+          <a:stretch/>
+        </p:blipFill>
+        <p:spPr>
+          <a:xfrm>
+            <a:off x="5896018" y="1357468"/>
+            <a:ext cx="684000" cy="684000"/>
+          </a:xfrm>
+          <a:prstGeom prst="rect">
+            <a:avLst/>
+          </a:prstGeom>
+        </p:spPr>
+      </p:pic>
+      <p:pic>
+        <p:nvPicPr>
+          <p:cNvPr id="75" name="Graphic 74" descr="Flowers in pot with solid fill">
+            <a:extLst>
+              <a:ext uri="{FF2B5EF4-FFF2-40B4-BE49-F238E27FC236}">
+                <a16:creationId xmlns:a16="http://schemas.microsoft.com/office/drawing/2014/main" id="{84D2A5A2-F113-F6EC-1FF5-89ED40E08369}"/>
+              </a:ext>
+            </a:extLst>
+          </p:cNvPr>
+          <p:cNvPicPr>
+            <a:picLocks noChangeAspect="1"/>
+          </p:cNvPicPr>
+          <p:nvPr/>
+        </p:nvPicPr>
+        <p:blipFill>
+          <a:blip>
+            <a:extLst>
+              <a:ext uri="{96DAC541-7B7A-43D3-8B79-37D633B846F1}">
+                <asvg:svgBlip xmlns:asvg="http://schemas.microsoft.com/office/drawing/2016/SVG/main" r:embed="rId15"/>
+              </a:ext>
+            </a:extLst>
+          </a:blip>
+          <a:srcRect/>
+          <a:stretch/>
+        </p:blipFill>
+        <p:spPr>
+          <a:xfrm>
+            <a:off x="5892188" y="2590485"/>
+            <a:ext cx="684000" cy="684000"/>
+          </a:xfrm>
+          <a:prstGeom prst="rect">
+            <a:avLst/>
+          </a:prstGeom>
+        </p:spPr>
+      </p:pic>
+      <p:pic>
+        <p:nvPicPr>
+          <p:cNvPr id="76" name="Graphic 75" descr="Flowers in pot with solid fill">
+            <a:extLst>
+              <a:ext uri="{FF2B5EF4-FFF2-40B4-BE49-F238E27FC236}">
+                <a16:creationId xmlns:a16="http://schemas.microsoft.com/office/drawing/2014/main" id="{BD9FDABA-C595-A52C-D2F5-E29814D608D5}"/>
+              </a:ext>
+            </a:extLst>
+          </p:cNvPr>
+          <p:cNvPicPr>
+            <a:picLocks noChangeAspect="1"/>
+          </p:cNvPicPr>
+          <p:nvPr/>
+        </p:nvPicPr>
+        <p:blipFill>
+          <a:blip>
+            <a:extLst>
+              <a:ext uri="{96DAC541-7B7A-43D3-8B79-37D633B846F1}">
+                <asvg:svgBlip xmlns:asvg="http://schemas.microsoft.com/office/drawing/2016/SVG/main" r:embed="rId16"/>
+              </a:ext>
+            </a:extLst>
+          </a:blip>
+          <a:srcRect/>
+          <a:stretch/>
+        </p:blipFill>
+        <p:spPr>
+          <a:xfrm>
+            <a:off x="5888358" y="1982936"/>
+            <a:ext cx="684000" cy="684000"/>
+          </a:xfrm>
+          <a:prstGeom prst="rect">
+            <a:avLst/>
+          </a:prstGeom>
+        </p:spPr>
+      </p:pic>
+      <p:pic>
+        <p:nvPicPr>
+          <p:cNvPr id="77" name="Graphic 76" descr="Flowers in pot with solid fill">
+            <a:extLst>
+              <a:ext uri="{FF2B5EF4-FFF2-40B4-BE49-F238E27FC236}">
+                <a16:creationId xmlns:a16="http://schemas.microsoft.com/office/drawing/2014/main" id="{F86E619F-D958-C9D7-8BAD-F0BD5C397DE7}"/>
+              </a:ext>
+            </a:extLst>
+          </p:cNvPr>
+          <p:cNvPicPr>
+            <a:picLocks noChangeAspect="1"/>
+          </p:cNvPicPr>
+          <p:nvPr/>
+        </p:nvPicPr>
+        <p:blipFill>
+          <a:blip>
+            <a:extLst>
+              <a:ext uri="{96DAC541-7B7A-43D3-8B79-37D633B846F1}">
+                <asvg:svgBlip xmlns:asvg="http://schemas.microsoft.com/office/drawing/2016/SVG/main" r:embed="rId17"/>
+              </a:ext>
+            </a:extLst>
+          </a:blip>
+          <a:srcRect/>
+          <a:stretch/>
+        </p:blipFill>
+        <p:spPr>
+          <a:xfrm>
+            <a:off x="5896018" y="3189704"/>
+            <a:ext cx="684000" cy="684000"/>
+          </a:xfrm>
+          <a:prstGeom prst="rect">
+            <a:avLst/>
+          </a:prstGeom>
+        </p:spPr>
+      </p:pic>
+      <p:pic>
+        <p:nvPicPr>
+          <p:cNvPr id="78" name="Graphic 77" descr="Wilting Pot Plant with solid fill">
+            <a:extLst>
+              <a:ext uri="{FF2B5EF4-FFF2-40B4-BE49-F238E27FC236}">
+                <a16:creationId xmlns:a16="http://schemas.microsoft.com/office/drawing/2014/main" id="{2923112A-FFD6-EDC1-7185-2222115EB7CC}"/>
+              </a:ext>
+            </a:extLst>
+          </p:cNvPr>
+          <p:cNvPicPr>
+            <a:picLocks noChangeAspect="1"/>
+          </p:cNvPicPr>
+          <p:nvPr/>
+        </p:nvPicPr>
+        <p:blipFill>
+          <a:blip>
+            <a:extLst>
+              <a:ext uri="{96DAC541-7B7A-43D3-8B79-37D633B846F1}">
+                <asvg:svgBlip xmlns:asvg="http://schemas.microsoft.com/office/drawing/2016/SVG/main" r:embed="rId18"/>
+              </a:ext>
+            </a:extLst>
+          </a:blip>
+          <a:srcRect/>
+          <a:stretch/>
+        </p:blipFill>
+        <p:spPr>
+          <a:xfrm>
+            <a:off x="10260490" y="3216394"/>
+            <a:ext cx="648000" cy="648000"/>
+          </a:xfrm>
+          <a:prstGeom prst="rect">
+            <a:avLst/>
+          </a:prstGeom>
+        </p:spPr>
+      </p:pic>
+      <p:pic>
+        <p:nvPicPr>
+          <p:cNvPr id="79" name="Graphic 78" descr="Flowers in pot with solid fill">
+            <a:extLst>
+              <a:ext uri="{FF2B5EF4-FFF2-40B4-BE49-F238E27FC236}">
+                <a16:creationId xmlns:a16="http://schemas.microsoft.com/office/drawing/2014/main" id="{F7EA73F3-FDED-8CEA-533C-8C3B571A84DB}"/>
+              </a:ext>
+            </a:extLst>
+          </p:cNvPr>
+          <p:cNvPicPr>
+            <a:picLocks noChangeAspect="1"/>
+          </p:cNvPicPr>
+          <p:nvPr/>
+        </p:nvPicPr>
+        <p:blipFill>
+          <a:blip>
+            <a:extLst>
+              <a:ext uri="{96DAC541-7B7A-43D3-8B79-37D633B846F1}">
+                <asvg:svgBlip xmlns:asvg="http://schemas.microsoft.com/office/drawing/2016/SVG/main" r:embed="rId19"/>
+              </a:ext>
+            </a:extLst>
+          </a:blip>
+          <a:srcRect/>
+          <a:stretch/>
+        </p:blipFill>
+        <p:spPr>
+          <a:xfrm>
+            <a:off x="5896018" y="3782385"/>
+            <a:ext cx="684000" cy="684000"/>
+          </a:xfrm>
+          <a:prstGeom prst="rect">
+            <a:avLst/>
+          </a:prstGeom>
+        </p:spPr>
+      </p:pic>
+      <p:sp>
+        <p:nvSpPr>
+          <p:cNvPr id="80" name="TextBox 79">
+            <a:extLst>
+              <a:ext uri="{FF2B5EF4-FFF2-40B4-BE49-F238E27FC236}">
+                <a16:creationId xmlns:a16="http://schemas.microsoft.com/office/drawing/2014/main" id="{68BB3514-9820-B0C6-913F-0AFD05589C0F}"/>
+              </a:ext>
+            </a:extLst>
+          </p:cNvPr>
+          <p:cNvSpPr txBox="1"/>
+          <p:nvPr/>
+        </p:nvSpPr>
+        <p:spPr>
+          <a:xfrm>
+            <a:off x="6366446" y="4689476"/>
+            <a:ext cx="2888521" cy="369332"/>
+          </a:xfrm>
+          <a:prstGeom prst="rect">
+            <a:avLst/>
+          </a:prstGeom>
+          <a:noFill/>
+        </p:spPr>
+        <p:txBody>
+          <a:bodyPr wrap="square" rtlCol="0">
+            <a:spAutoFit/>
+          </a:bodyPr>
+          <a:lstStyle/>
+          <a:p>
+            <a:r>
+              <a:rPr lang="en-GB" b="1" dirty="0"/>
+              <a:t>Event: </a:t>
+            </a:r>
+            <a:r>
+              <a:rPr lang="en-GB" dirty="0"/>
+              <a:t>plant flowering</a:t>
+            </a:r>
+          </a:p>
+        </p:txBody>
+      </p:sp>
+      <p:pic>
+        <p:nvPicPr>
+          <p:cNvPr id="82" name="Graphic 81" descr="Flower without stem with solid fill">
+            <a:extLst>
+              <a:ext uri="{FF2B5EF4-FFF2-40B4-BE49-F238E27FC236}">
+                <a16:creationId xmlns:a16="http://schemas.microsoft.com/office/drawing/2014/main" id="{4C85A1CF-C0CF-0763-05CF-71B9BAB07DE5}"/>
+              </a:ext>
+            </a:extLst>
+          </p:cNvPr>
+          <p:cNvPicPr>
+            <a:picLocks noChangeAspect="1"/>
+          </p:cNvPicPr>
+          <p:nvPr/>
+        </p:nvPicPr>
+        <p:blipFill>
+          <a:blip>
+            <a:extLst>
+              <a:ext uri="{96DAC541-7B7A-43D3-8B79-37D633B846F1}">
+                <asvg:svgBlip xmlns:asvg="http://schemas.microsoft.com/office/drawing/2016/SVG/main" r:embed="rId20"/>
+              </a:ext>
+            </a:extLst>
+          </a:blip>
+          <a:srcRect/>
+          <a:stretch/>
+        </p:blipFill>
+        <p:spPr>
+          <a:xfrm>
+            <a:off x="8637054" y="2588680"/>
+            <a:ext cx="761707" cy="761707"/>
+          </a:xfrm>
+          <a:prstGeom prst="rect">
+            <a:avLst/>
+          </a:prstGeom>
+        </p:spPr>
+      </p:pic>
+      <p:sp>
+        <p:nvSpPr>
+          <p:cNvPr id="84" name="Rectangle 83">
+            <a:extLst>
+              <a:ext uri="{FF2B5EF4-FFF2-40B4-BE49-F238E27FC236}">
+                <a16:creationId xmlns:a16="http://schemas.microsoft.com/office/drawing/2014/main" id="{A63F6D05-0E84-77FD-AADB-94DD861DEED2}"/>
+              </a:ext>
+            </a:extLst>
+          </p:cNvPr>
+          <p:cNvSpPr/>
+          <p:nvPr/>
+        </p:nvSpPr>
+        <p:spPr>
+          <a:xfrm>
+            <a:off x="6728884" y="2290621"/>
+            <a:ext cx="3744000" cy="190375"/>
+          </a:xfrm>
+          <a:prstGeom prst="rect">
+            <a:avLst/>
+          </a:prstGeom>
+          <a:solidFill>
+            <a:srgbClr val="00B1C1"/>
+          </a:solidFill>
+          <a:ln>
+            <a:solidFill>
+              <a:schemeClr val="accent5"/>
+            </a:solidFill>
+          </a:ln>
+        </p:spPr>
+        <p:style>
+          <a:lnRef idx="2">
+            <a:schemeClr val="accent1">
+              <a:shade val="15000"/>
+            </a:schemeClr>
+          </a:lnRef>
+          <a:fillRef idx="1">
+            <a:schemeClr val="accent1"/>
+          </a:fillRef>
+          <a:effectRef idx="0">
+            <a:schemeClr val="accent1"/>
+          </a:effectRef>
+          <a:fontRef idx="minor">
+            <a:schemeClr val="lt1"/>
+          </a:fontRef>
+        </p:style>
+        <p:txBody>
+          <a:bodyPr rtlCol="0" anchor="ctr"/>
+          <a:lstStyle/>
+          <a:p>
+            <a:pPr algn="ctr"/>
+            <a:endParaRPr lang="en-GB"/>
+          </a:p>
+        </p:txBody>
+      </p:sp>
+      <p:pic>
+        <p:nvPicPr>
+          <p:cNvPr id="69" name="Graphic 68" descr="Wilting Pot Plant with solid fill">
+            <a:extLst>
+              <a:ext uri="{FF2B5EF4-FFF2-40B4-BE49-F238E27FC236}">
+                <a16:creationId xmlns:a16="http://schemas.microsoft.com/office/drawing/2014/main" id="{673A43E1-F229-4C31-EA4D-EB7C0C329080}"/>
+              </a:ext>
+            </a:extLst>
+          </p:cNvPr>
+          <p:cNvPicPr>
+            <a:picLocks noChangeAspect="1"/>
+          </p:cNvPicPr>
+          <p:nvPr/>
+        </p:nvPicPr>
+        <p:blipFill>
+          <a:blip>
+            <a:extLst>
+              <a:ext uri="{96DAC541-7B7A-43D3-8B79-37D633B846F1}">
+                <asvg:svgBlip xmlns:asvg="http://schemas.microsoft.com/office/drawing/2016/SVG/main" r:embed="rId21"/>
+              </a:ext>
+            </a:extLst>
+          </a:blip>
+          <a:srcRect/>
+          <a:stretch/>
+        </p:blipFill>
+        <p:spPr>
+          <a:xfrm>
+            <a:off x="10496648" y="2018708"/>
+            <a:ext cx="648000" cy="648000"/>
+          </a:xfrm>
+          <a:prstGeom prst="rect">
+            <a:avLst/>
+          </a:prstGeom>
+        </p:spPr>
+      </p:pic>
+      <p:cxnSp>
+        <p:nvCxnSpPr>
+          <p:cNvPr id="73" name="Straight Connector 72">
+            <a:extLst>
+              <a:ext uri="{FF2B5EF4-FFF2-40B4-BE49-F238E27FC236}">
+                <a16:creationId xmlns:a16="http://schemas.microsoft.com/office/drawing/2014/main" id="{C85586F4-9D33-2A1D-D0EA-0FC8FC4DE11A}"/>
+              </a:ext>
+            </a:extLst>
+          </p:cNvPr>
+          <p:cNvCxnSpPr>
+            <a:cxnSpLocks/>
+          </p:cNvCxnSpPr>
+          <p:nvPr/>
+        </p:nvCxnSpPr>
+        <p:spPr>
+          <a:xfrm>
+            <a:off x="6728885" y="1386699"/>
+            <a:ext cx="0" cy="3170067"/>
+          </a:xfrm>
+          <a:prstGeom prst="line">
+            <a:avLst/>
+          </a:prstGeom>
+          <a:ln w="38100">
+            <a:solidFill>
+              <a:schemeClr val="tx1"/>
+            </a:solidFill>
+            <a:prstDash val="solid"/>
+          </a:ln>
+        </p:spPr>
+        <p:style>
+          <a:lnRef idx="1">
+            <a:schemeClr val="accent1"/>
+          </a:lnRef>
+          <a:fillRef idx="0">
+            <a:schemeClr val="accent1"/>
+          </a:fillRef>
+          <a:effectRef idx="0">
+            <a:schemeClr val="accent1"/>
+          </a:effectRef>
+          <a:fontRef idx="minor">
+            <a:schemeClr val="tx1"/>
+          </a:fontRef>
+        </p:style>
+      </p:cxnSp>
+      <p:cxnSp>
+        <p:nvCxnSpPr>
+          <p:cNvPr id="86" name="Straight Connector 85">
+            <a:extLst>
+              <a:ext uri="{FF2B5EF4-FFF2-40B4-BE49-F238E27FC236}">
+                <a16:creationId xmlns:a16="http://schemas.microsoft.com/office/drawing/2014/main" id="{7CB05A11-F26B-200B-6B88-BC088E68E35D}"/>
+              </a:ext>
+            </a:extLst>
+          </p:cNvPr>
+          <p:cNvCxnSpPr/>
+          <p:nvPr/>
+        </p:nvCxnSpPr>
+        <p:spPr>
+          <a:xfrm flipV="1">
+            <a:off x="10468999" y="2178776"/>
+            <a:ext cx="0" cy="409904"/>
+          </a:xfrm>
+          <a:prstGeom prst="line">
+            <a:avLst/>
+          </a:prstGeom>
+          <a:ln w="57150">
+            <a:solidFill>
+              <a:schemeClr val="accent5"/>
+            </a:solidFill>
+          </a:ln>
+        </p:spPr>
+        <p:style>
+          <a:lnRef idx="2">
+            <a:schemeClr val="accent1"/>
+          </a:lnRef>
+          <a:fillRef idx="0">
+            <a:schemeClr val="accent1"/>
+          </a:fillRef>
+          <a:effectRef idx="1">
+            <a:schemeClr val="accent1"/>
+          </a:effectRef>
+          <a:fontRef idx="minor">
+            <a:schemeClr val="tx1"/>
+          </a:fontRef>
+        </p:style>
+      </p:cxnSp>
+      <p:cxnSp>
+        <p:nvCxnSpPr>
+          <p:cNvPr id="87" name="Straight Connector 86">
+            <a:extLst>
+              <a:ext uri="{FF2B5EF4-FFF2-40B4-BE49-F238E27FC236}">
+                <a16:creationId xmlns:a16="http://schemas.microsoft.com/office/drawing/2014/main" id="{C37AAE16-1E49-137D-E134-A9034AB23A37}"/>
+              </a:ext>
+            </a:extLst>
+          </p:cNvPr>
+          <p:cNvCxnSpPr/>
+          <p:nvPr/>
+        </p:nvCxnSpPr>
+        <p:spPr>
+          <a:xfrm flipV="1">
+            <a:off x="10264681" y="3411363"/>
+            <a:ext cx="0" cy="409904"/>
+          </a:xfrm>
+          <a:prstGeom prst="line">
+            <a:avLst/>
+          </a:prstGeom>
+          <a:ln w="57150">
+            <a:solidFill>
+              <a:schemeClr val="accent1"/>
+            </a:solidFill>
+          </a:ln>
+        </p:spPr>
+        <p:style>
+          <a:lnRef idx="2">
+            <a:schemeClr val="accent1"/>
+          </a:lnRef>
+          <a:fillRef idx="0">
+            <a:schemeClr val="accent1"/>
+          </a:fillRef>
+          <a:effectRef idx="1">
+            <a:schemeClr val="accent1"/>
+          </a:effectRef>
+          <a:fontRef idx="minor">
+            <a:schemeClr val="tx1"/>
+          </a:fontRef>
+        </p:style>
+      </p:cxnSp>
+    </p:spTree>
+    <p:extLst>
+      <p:ext uri="{BB962C8B-B14F-4D97-AF65-F5344CB8AC3E}">
+        <p14:creationId xmlns:p14="http://schemas.microsoft.com/office/powerpoint/2010/main" val="343977838"/>
+      </p:ext>
+    </p:extLst>
+  </p:cSld>
+  <p:clrMapOvr>
+    <a:masterClrMapping/>
+  </p:clrMapOvr>
+</p:sld>
+</file>
+
 <file path=ppt/theme/theme1.xml><?xml version="1.0" encoding="utf-8"?>
 <a:theme xmlns:a="http://schemas.openxmlformats.org/drawingml/2006/main" name="Office Theme">
   <a:themeElements>

</xml_diff>